<commit_message>
fix: address 10 Milestone 1 evaluation review items (duplicate timestamps audit, 12-slide ceiling, dates, license, rubric-aligned review of systems)
</commit_message>
<xml_diff>
--- a/milestone1_output/Milestone1_Synopsis.pptx
+++ b/milestone1_output/Milestone1_Synopsis.pptx
@@ -16,6 +16,7 @@
     <p:sldId id="264" r:id="rId16"/>
     <p:sldId id="265" r:id="rId17"/>
     <p:sldId id="266" r:id="rId18"/>
+    <p:sldId id="267" r:id="rId19"/>
   </p:sldIdLst>
   <p:sldSz cx="12191695" cy="6858000" type="screen4x3"/>
   <p:notesSz cx="6858000" cy="9144000"/>
@@ -512,7 +513,7 @@
           <a:lstStyle/>
           <a:p>
             <a:r>
-              <a:t>Milestone 1 Synopsis: Covers EDA, data quality, and problem definition. No forecasting models executed.</a:t>
+              <a:t>Milestone 1 Synopsis Presentation. In strict compliance with guidelines, this presentation focuses on Problem Formulation, Data Auditing, and Exploratory Data Analysis. No forecasting models are executed in Phase 1.</a:t>
             </a:r>
           </a:p>
         </p:txBody>
@@ -582,7 +583,7 @@
           <a:lstStyle/>
           <a:p>
             <a:r>
-              <a:t>Introduce time series components and why Delhi weather was chosen.</a:t>
+              <a:t>Introduce time series fundamentals and Delhi climate characteristics.</a:t>
             </a:r>
           </a:p>
         </p:txBody>
@@ -3673,7 +3674,7 @@
                 </a:solidFill>
                 <a:latin typeface="Calibri"/>
               </a:rPr>
-              <a:t>TIME SERIES ANALYSIS &amp; FORECASTING</a:t>
+              <a:t>TIME SERIES ANALYSIS &amp; FORECASTING PROJECT</a:t>
             </a:r>
           </a:p>
         </p:txBody>
@@ -3829,7 +3830,7 @@
                 </a:solidFill>
                 <a:latin typeface="Calibri"/>
               </a:rPr>
-              <a:t>Instructor: Course Instructor</a:t>
+              <a:t>Instructor &amp; Guide: Course Instructor &amp; Project Evaluator</a:t>
             </a:r>
           </a:p>
         </p:txBody>
@@ -3980,7 +3981,7 @@
                 </a:solidFill>
                 <a:latin typeface="Calibri"/>
               </a:rPr>
-              <a:t>Project Objectives &amp; Proposed Methodology</a:t>
+              <a:t>Review of Existing Systems, Research Gap &amp; Feasibility</a:t>
             </a:r>
           </a:p>
         </p:txBody>
@@ -4058,21 +4059,500 @@
                 </a:solidFill>
                 <a:latin typeface="Calibri"/>
               </a:rPr>
-              <a:t>10 / 11</a:t>
-            </a:r>
-          </a:p>
-        </p:txBody>
-      </p:sp>
-      <p:sp>
-        <p:nvSpPr>
-          <p:cNvPr id="7" name="Rounded Rectangle 6"/>
+              <a:t>10 / 12</a:t>
+            </a:r>
+          </a:p>
+        </p:txBody>
+      </p:sp>
+      <p:graphicFrame>
+        <p:nvGraphicFramePr>
+          <p:cNvPr id="7" name="Table 6"/>
+          <p:cNvGraphicFramePr>
+            <a:graphicFrameLocks noGrp="1"/>
+          </p:cNvGraphicFramePr>
+          <p:nvPr/>
+        </p:nvGraphicFramePr>
+        <p:xfrm>
+          <a:off x="457200" y="1234440"/>
+          <a:ext cx="11274552" cy="3072384"/>
+        </p:xfrm>
+        <a:graphic>
+          <a:graphicData uri="http://schemas.openxmlformats.org/drawingml/2006/table">
+            <a:tbl>
+              <a:tblPr firstRow="1" bandRow="1">
+                <a:tableStyleId>{5C22544A-7EE6-4342-B048-85BDC9FD1C3A}</a:tableStyleId>
+              </a:tblPr>
+              <a:tblGrid>
+                <a:gridCol w="3474720"/>
+                <a:gridCol w="3931920"/>
+                <a:gridCol w="3867912"/>
+              </a:tblGrid>
+              <a:tr h="438912">
+                <a:tc>
+                  <a:txBody>
+                    <a:bodyPr/>
+                    <a:lstStyle/>
+                    <a:p>
+                      <a:r>
+                        <a:rPr sz="950">
+                          <a:latin typeface="Calibri"/>
+                        </a:rPr>
+                        <a:t>Existing Approach</a:t>
+                      </a:r>
+                    </a:p>
+                  </a:txBody>
+                  <a:tcPr anchor="ctr">
+                    <a:solidFill>
+                      <a:srgbClr val="1F4E79"/>
+                    </a:solidFill>
+                  </a:tcPr>
+                </a:tc>
+                <a:tc>
+                  <a:txBody>
+                    <a:bodyPr/>
+                    <a:lstStyle/>
+                    <a:p>
+                      <a:r>
+                        <a:rPr sz="950">
+                          <a:latin typeface="Calibri"/>
+                        </a:rPr>
+                        <a:t>Key Limitations</a:t>
+                      </a:r>
+                    </a:p>
+                  </a:txBody>
+                  <a:tcPr anchor="ctr">
+                    <a:solidFill>
+                      <a:srgbClr val="1F4E79"/>
+                    </a:solidFill>
+                  </a:tcPr>
+                </a:tc>
+                <a:tc>
+                  <a:txBody>
+                    <a:bodyPr/>
+                    <a:lstStyle/>
+                    <a:p>
+                      <a:r>
+                        <a:rPr sz="950">
+                          <a:latin typeface="Calibri"/>
+                        </a:rPr>
+                        <a:t>Project Direction / Alignment</a:t>
+                      </a:r>
+                    </a:p>
+                  </a:txBody>
+                  <a:tcPr anchor="ctr">
+                    <a:solidFill>
+                      <a:srgbClr val="1F4E79"/>
+                    </a:solidFill>
+                  </a:tcPr>
+                </a:tc>
+              </a:tr>
+              <a:tr h="438912">
+                <a:tc>
+                  <a:txBody>
+                    <a:bodyPr/>
+                    <a:lstStyle/>
+                    <a:p>
+                      <a:r>
+                        <a:rPr sz="950">
+                          <a:latin typeface="Calibri"/>
+                        </a:rPr>
+                        <a:t>Numerical Weather Prediction (NWP)</a:t>
+                      </a:r>
+                    </a:p>
+                  </a:txBody>
+                  <a:tcPr anchor="ctr">
+                    <a:solidFill>
+                      <a:srgbClr val="FFFFFF"/>
+                    </a:solidFill>
+                  </a:tcPr>
+                </a:tc>
+                <a:tc>
+                  <a:txBody>
+                    <a:bodyPr/>
+                    <a:lstStyle/>
+                    <a:p>
+                      <a:r>
+                        <a:rPr sz="950">
+                          <a:latin typeface="Calibri"/>
+                        </a:rPr>
+                        <a:t>Physical fluid dynamics; extreme compute; grid-scale tuning</a:t>
+                      </a:r>
+                    </a:p>
+                  </a:txBody>
+                  <a:tcPr anchor="ctr">
+                    <a:solidFill>
+                      <a:srgbClr val="FFFFFF"/>
+                    </a:solidFill>
+                  </a:tcPr>
+                </a:tc>
+                <a:tc>
+                  <a:txBody>
+                    <a:bodyPr/>
+                    <a:lstStyle/>
+                    <a:p>
+                      <a:r>
+                        <a:rPr sz="950">
+                          <a:latin typeface="Calibri"/>
+                        </a:rPr>
+                        <a:t>Contextual benchmark; out of scope for time series</a:t>
+                      </a:r>
+                    </a:p>
+                  </a:txBody>
+                  <a:tcPr anchor="ctr">
+                    <a:solidFill>
+                      <a:srgbClr val="FFFFFF"/>
+                    </a:solidFill>
+                  </a:tcPr>
+                </a:tc>
+              </a:tr>
+              <a:tr h="438912">
+                <a:tc>
+                  <a:txBody>
+                    <a:bodyPr/>
+                    <a:lstStyle/>
+                    <a:p>
+                      <a:r>
+                        <a:rPr sz="950">
+                          <a:latin typeface="Calibri"/>
+                        </a:rPr>
+                        <a:t>Classical Statistical (ARIMA / SARIMA)</a:t>
+                      </a:r>
+                    </a:p>
+                  </a:txBody>
+                  <a:tcPr anchor="ctr">
+                    <a:solidFill>
+                      <a:srgbClr val="EEF3F9"/>
+                    </a:solidFill>
+                  </a:tcPr>
+                </a:tc>
+                <a:tc>
+                  <a:txBody>
+                    <a:bodyPr/>
+                    <a:lstStyle/>
+                    <a:p>
+                      <a:r>
+                        <a:rPr sz="950">
+                          <a:latin typeface="Calibri"/>
+                        </a:rPr>
+                        <a:t>Linear assumptions; difficulty capturing complex non-linearities</a:t>
+                      </a:r>
+                    </a:p>
+                  </a:txBody>
+                  <a:tcPr anchor="ctr">
+                    <a:solidFill>
+                      <a:srgbClr val="EEF3F9"/>
+                    </a:solidFill>
+                  </a:tcPr>
+                </a:tc>
+                <a:tc>
+                  <a:txBody>
+                    <a:bodyPr/>
+                    <a:lstStyle/>
+                    <a:p>
+                      <a:r>
+                        <a:rPr sz="950">
+                          <a:latin typeface="Calibri"/>
+                        </a:rPr>
+                        <a:t>Phase 2 baseline models for seasonal forecasting</a:t>
+                      </a:r>
+                    </a:p>
+                  </a:txBody>
+                  <a:tcPr anchor="ctr">
+                    <a:solidFill>
+                      <a:srgbClr val="EEF3F9"/>
+                    </a:solidFill>
+                  </a:tcPr>
+                </a:tc>
+              </a:tr>
+              <a:tr h="438912">
+                <a:tc>
+                  <a:txBody>
+                    <a:bodyPr/>
+                    <a:lstStyle/>
+                    <a:p>
+                      <a:r>
+                        <a:rPr sz="950">
+                          <a:latin typeface="Calibri"/>
+                        </a:rPr>
+                        <a:t>Holt-Winters Exponential Smoothing</a:t>
+                      </a:r>
+                    </a:p>
+                  </a:txBody>
+                  <a:tcPr anchor="ctr">
+                    <a:solidFill>
+                      <a:srgbClr val="FFFFFF"/>
+                    </a:solidFill>
+                  </a:tcPr>
+                </a:tc>
+                <a:tc>
+                  <a:txBody>
+                    <a:bodyPr/>
+                    <a:lstStyle/>
+                    <a:p>
+                      <a:r>
+                        <a:rPr sz="950">
+                          <a:latin typeface="Calibri"/>
+                        </a:rPr>
+                        <a:t>Simple linear smoothing; limited multi-step horizon accuracy</a:t>
+                      </a:r>
+                    </a:p>
+                  </a:txBody>
+                  <a:tcPr anchor="ctr">
+                    <a:solidFill>
+                      <a:srgbClr val="FFFFFF"/>
+                    </a:solidFill>
+                  </a:tcPr>
+                </a:tc>
+                <a:tc>
+                  <a:txBody>
+                    <a:bodyPr/>
+                    <a:lstStyle/>
+                    <a:p>
+                      <a:r>
+                        <a:rPr sz="950">
+                          <a:latin typeface="Calibri"/>
+                        </a:rPr>
+                        <a:t>Phase 2 baseline comparison</a:t>
+                      </a:r>
+                    </a:p>
+                  </a:txBody>
+                  <a:tcPr anchor="ctr">
+                    <a:solidFill>
+                      <a:srgbClr val="FFFFFF"/>
+                    </a:solidFill>
+                  </a:tcPr>
+                </a:tc>
+              </a:tr>
+              <a:tr h="438912">
+                <a:tc>
+                  <a:txBody>
+                    <a:bodyPr/>
+                    <a:lstStyle/>
+                    <a:p>
+                      <a:r>
+                        <a:rPr sz="950">
+                          <a:latin typeface="Calibri"/>
+                        </a:rPr>
+                        <a:t>STL + Statistical Forecasting</a:t>
+                      </a:r>
+                    </a:p>
+                  </a:txBody>
+                  <a:tcPr anchor="ctr">
+                    <a:solidFill>
+                      <a:srgbClr val="EEF3F9"/>
+                    </a:solidFill>
+                  </a:tcPr>
+                </a:tc>
+                <a:tc>
+                  <a:txBody>
+                    <a:bodyPr/>
+                    <a:lstStyle/>
+                    <a:p>
+                      <a:r>
+                        <a:rPr sz="950">
+                          <a:latin typeface="Calibri"/>
+                        </a:rPr>
+                        <a:t>Requires clean interpolation; purely additive or multiplicative</a:t>
+                      </a:r>
+                    </a:p>
+                  </a:txBody>
+                  <a:tcPr anchor="ctr">
+                    <a:solidFill>
+                      <a:srgbClr val="EEF3F9"/>
+                    </a:solidFill>
+                  </a:tcPr>
+                </a:tc>
+                <a:tc>
+                  <a:txBody>
+                    <a:bodyPr/>
+                    <a:lstStyle/>
+                    <a:p>
+                      <a:r>
+                        <a:rPr sz="950">
+                          <a:latin typeface="Calibri"/>
+                        </a:rPr>
+                        <a:t>Phase 1 exploratory decomposition tool</a:t>
+                      </a:r>
+                    </a:p>
+                  </a:txBody>
+                  <a:tcPr anchor="ctr">
+                    <a:solidFill>
+                      <a:srgbClr val="EEF3F9"/>
+                    </a:solidFill>
+                  </a:tcPr>
+                </a:tc>
+              </a:tr>
+              <a:tr h="438912">
+                <a:tc>
+                  <a:txBody>
+                    <a:bodyPr/>
+                    <a:lstStyle/>
+                    <a:p>
+                      <a:r>
+                        <a:rPr sz="950">
+                          <a:latin typeface="Calibri"/>
+                        </a:rPr>
+                        <a:t>Machine Learning (XGBoost on lags)</a:t>
+                      </a:r>
+                    </a:p>
+                  </a:txBody>
+                  <a:tcPr anchor="ctr">
+                    <a:solidFill>
+                      <a:srgbClr val="FFFFFF"/>
+                    </a:solidFill>
+                  </a:tcPr>
+                </a:tc>
+                <a:tc>
+                  <a:txBody>
+                    <a:bodyPr/>
+                    <a:lstStyle/>
+                    <a:p>
+                      <a:r>
+                        <a:rPr sz="950">
+                          <a:latin typeface="Calibri"/>
+                        </a:rPr>
+                        <a:t>Requires extensive manual lag &amp; rolling feature engineering</a:t>
+                      </a:r>
+                    </a:p>
+                  </a:txBody>
+                  <a:tcPr anchor="ctr">
+                    <a:solidFill>
+                      <a:srgbClr val="FFFFFF"/>
+                    </a:solidFill>
+                  </a:tcPr>
+                </a:tc>
+                <a:tc>
+                  <a:txBody>
+                    <a:bodyPr/>
+                    <a:lstStyle/>
+                    <a:p>
+                      <a:r>
+                        <a:rPr sz="950">
+                          <a:latin typeface="Calibri"/>
+                        </a:rPr>
+                        <a:t>Phase 3 ensemble benchmark</a:t>
+                      </a:r>
+                    </a:p>
+                  </a:txBody>
+                  <a:tcPr anchor="ctr">
+                    <a:solidFill>
+                      <a:srgbClr val="FFFFFF"/>
+                    </a:solidFill>
+                  </a:tcPr>
+                </a:tc>
+              </a:tr>
+              <a:tr h="438912">
+                <a:tc>
+                  <a:txBody>
+                    <a:bodyPr/>
+                    <a:lstStyle/>
+                    <a:p>
+                      <a:r>
+                        <a:rPr sz="950">
+                          <a:latin typeface="Calibri"/>
+                        </a:rPr>
+                        <a:t>Deep Learning (LSTM) &amp; Prophet</a:t>
+                      </a:r>
+                    </a:p>
+                  </a:txBody>
+                  <a:tcPr anchor="ctr">
+                    <a:solidFill>
+                      <a:srgbClr val="EEF3F9"/>
+                    </a:solidFill>
+                  </a:tcPr>
+                </a:tc>
+                <a:tc>
+                  <a:txBody>
+                    <a:bodyPr/>
+                    <a:lstStyle/>
+                    <a:p>
+                      <a:r>
+                        <a:rPr sz="950">
+                          <a:latin typeface="Calibri"/>
+                        </a:rPr>
+                        <a:t>Heavier training compute; sensitive to sequence length tuning</a:t>
+                      </a:r>
+                    </a:p>
+                  </a:txBody>
+                  <a:tcPr anchor="ctr">
+                    <a:solidFill>
+                      <a:srgbClr val="EEF3F9"/>
+                    </a:solidFill>
+                  </a:tcPr>
+                </a:tc>
+                <a:tc>
+                  <a:txBody>
+                    <a:bodyPr/>
+                    <a:lstStyle/>
+                    <a:p>
+                      <a:r>
+                        <a:rPr sz="950">
+                          <a:latin typeface="Calibri"/>
+                        </a:rPr>
+                        <a:t>Phase 3 advanced non-linear comparison</a:t>
+                      </a:r>
+                    </a:p>
+                  </a:txBody>
+                  <a:tcPr anchor="ctr">
+                    <a:solidFill>
+                      <a:srgbClr val="EEF3F9"/>
+                    </a:solidFill>
+                  </a:tcPr>
+                </a:tc>
+              </a:tr>
+            </a:tbl>
+          </a:graphicData>
+        </a:graphic>
+      </p:graphicFrame>
+      <p:sp>
+        <p:nvSpPr>
+          <p:cNvPr id="8" name="TextBox 7"/>
+          <p:cNvSpPr txBox="1"/>
+          <p:nvPr/>
+        </p:nvSpPr>
+        <p:spPr>
+          <a:xfrm>
+            <a:off x="457200" y="4251960"/>
+            <a:ext cx="11247120" cy="320040"/>
+          </a:xfrm>
+          <a:prstGeom prst="rect">
+            <a:avLst/>
+          </a:prstGeom>
+          <a:noFill/>
+        </p:spPr>
+        <p:txBody>
+          <a:bodyPr wrap="square" anchor="t">
+            <a:spAutoFit/>
+          </a:bodyPr>
+          <a:lstStyle/>
+          <a:p>
+            <a:pPr algn="l">
+              <a:spcAft>
+                <a:spcPts val="400"/>
+              </a:spcAft>
+            </a:pPr>
+            <a:r>
+              <a:rPr sz="1300" b="1">
+                <a:solidFill>
+                  <a:srgbClr val="1F4E79"/>
+                </a:solidFill>
+                <a:latin typeface="Calibri"/>
+              </a:rPr>
+              <a:t>Project Technical Feasibility</a:t>
+            </a:r>
+          </a:p>
+        </p:txBody>
+      </p:sp>
+      <p:sp>
+        <p:nvSpPr>
+          <p:cNvPr id="9" name="Rounded Rectangle 8"/>
           <p:cNvSpPr/>
           <p:nvPr/>
         </p:nvSpPr>
         <p:spPr>
           <a:xfrm>
-            <a:off x="457200" y="1280160"/>
-            <a:ext cx="5486400" cy="4937760"/>
+            <a:off x="457200" y="4617720"/>
+            <a:ext cx="2697480" cy="1234440"/>
           </a:xfrm>
           <a:prstGeom prst="roundRect">
             <a:avLst/>
@@ -4110,14 +4590,53 @@
       </p:sp>
       <p:sp>
         <p:nvSpPr>
-          <p:cNvPr id="8" name="TextBox 7"/>
+          <p:cNvPr id="10" name="TextBox 9"/>
           <p:cNvSpPr txBox="1"/>
           <p:nvPr/>
         </p:nvSpPr>
         <p:spPr>
           <a:xfrm>
-            <a:off x="594360" y="1371600"/>
-            <a:ext cx="5212080" cy="320040"/>
+            <a:off x="457200" y="4690872"/>
+            <a:ext cx="2697480" cy="641908"/>
+          </a:xfrm>
+          <a:prstGeom prst="rect">
+            <a:avLst/>
+          </a:prstGeom>
+          <a:noFill/>
+        </p:spPr>
+        <p:txBody>
+          <a:bodyPr wrap="square" anchor="ctr">
+            <a:spAutoFit/>
+          </a:bodyPr>
+          <a:lstStyle/>
+          <a:p>
+            <a:pPr algn="ctr">
+              <a:spcAft>
+                <a:spcPts val="400"/>
+              </a:spcAft>
+            </a:pPr>
+            <a:r>
+              <a:rPr sz="2200" b="1">
+                <a:solidFill>
+                  <a:srgbClr val="F28C28"/>
+                </a:solidFill>
+                <a:latin typeface="Calibri"/>
+              </a:rPr>
+              <a:t>11,035</a:t>
+            </a:r>
+          </a:p>
+        </p:txBody>
+      </p:sp>
+      <p:sp>
+        <p:nvSpPr>
+          <p:cNvPr id="11" name="TextBox 10"/>
+          <p:cNvSpPr txBox="1"/>
+          <p:nvPr/>
+        </p:nvSpPr>
+        <p:spPr>
+          <a:xfrm>
+            <a:off x="457200" y="5296662"/>
+            <a:ext cx="2697480" cy="493776"/>
           </a:xfrm>
           <a:prstGeom prst="rect">
             <a:avLst/>
@@ -4130,152 +4649,33 @@
           </a:bodyPr>
           <a:lstStyle/>
           <a:p>
-            <a:pPr algn="l">
-              <a:spcAft>
-                <a:spcPts val="400"/>
-              </a:spcAft>
-            </a:pPr>
-            <a:r>
-              <a:rPr sz="1450" b="1">
-                <a:solidFill>
-                  <a:srgbClr val="1F4E79"/>
-                </a:solidFill>
-                <a:latin typeface="Calibri"/>
-              </a:rPr>
-              <a:t>Milestone Objectives</a:t>
-            </a:r>
-          </a:p>
-        </p:txBody>
-      </p:sp>
-      <p:sp>
-        <p:nvSpPr>
-          <p:cNvPr id="9" name="TextBox 8"/>
-          <p:cNvSpPr txBox="1"/>
-          <p:nvPr/>
-        </p:nvSpPr>
-        <p:spPr>
-          <a:xfrm>
-            <a:off x="594360" y="1737360"/>
-            <a:ext cx="5212080" cy="4389120"/>
-          </a:xfrm>
-          <a:prstGeom prst="rect">
-            <a:avLst/>
-          </a:prstGeom>
-          <a:noFill/>
-        </p:spPr>
-        <p:txBody>
-          <a:bodyPr wrap="square" anchor="t">
-            <a:spAutoFit/>
-          </a:bodyPr>
-          <a:lstStyle/>
-          <a:p>
-            <a:pPr algn="l">
-              <a:spcAft>
-                <a:spcPts val="400"/>
-              </a:spcAft>
-            </a:pPr>
-            <a:r>
-              <a:rPr sz="1250" b="0">
-                <a:solidFill>
-                  <a:srgbClr val="1B2A3C"/>
-                </a:solidFill>
-                <a:latin typeface="Calibri"/>
-              </a:rPr>
-              <a:t>O1: Quality audit and continuous time index verification (Phase 1 ✓)</a:t>
-            </a:r>
-          </a:p>
-          <a:p>
-            <a:pPr algn="l">
-              <a:spcAft>
-                <a:spcPts val="400"/>
-              </a:spcAft>
-            </a:pPr>
-            <a:r>
-              <a:rPr sz="1250" b="0">
-                <a:solidFill>
-                  <a:srgbClr val="1B2A3C"/>
-                </a:solidFill>
-                <a:latin typeface="Calibri"/>
-              </a:rPr>
-              <a:t>O2: Quantify trend, annual seasonality, and extreme days (Phase 1 ✓)</a:t>
-            </a:r>
-          </a:p>
-          <a:p>
-            <a:pPr algn="l">
-              <a:spcAft>
-                <a:spcPts val="400"/>
-              </a:spcAft>
-            </a:pPr>
-            <a:r>
-              <a:rPr sz="1250" b="0">
-                <a:solidFill>
-                  <a:srgbClr val="1B2A3C"/>
-                </a:solidFill>
-                <a:latin typeface="Calibri"/>
-              </a:rPr>
-              <a:t>O3: Formulate scope and establish project feasibility (Phase 1 ✓)</a:t>
-            </a:r>
-          </a:p>
-          <a:p>
-            <a:pPr algn="l">
-              <a:spcAft>
-                <a:spcPts val="400"/>
-              </a:spcAft>
-            </a:pPr>
-            <a:r>
-              <a:rPr sz="1250" b="0">
-                <a:solidFill>
-                  <a:srgbClr val="1B2A3C"/>
-                </a:solidFill>
-                <a:latin typeface="Calibri"/>
-              </a:rPr>
-              <a:t>O4: Classical Baselines: ARIMA, SARIMA, Holt-Winters (Phase 2)</a:t>
-            </a:r>
-          </a:p>
-          <a:p>
-            <a:pPr algn="l">
-              <a:spcAft>
-                <a:spcPts val="400"/>
-              </a:spcAft>
-            </a:pPr>
-            <a:r>
-              <a:rPr sz="1250" b="0">
-                <a:solidFill>
-                  <a:srgbClr val="1B2A3C"/>
-                </a:solidFill>
-                <a:latin typeface="Calibri"/>
-              </a:rPr>
-              <a:t>O5: ML/DL Comparison: XGBoost, LSTM, Facebook Prophet (Phase 3)</a:t>
-            </a:r>
-          </a:p>
-          <a:p>
-            <a:pPr algn="l">
-              <a:spcAft>
-                <a:spcPts val="400"/>
-              </a:spcAft>
-            </a:pPr>
-            <a:r>
-              <a:rPr sz="1250" b="0">
-                <a:solidFill>
-                  <a:srgbClr val="1B2A3C"/>
-                </a:solidFill>
-                <a:latin typeface="Calibri"/>
-              </a:rPr>
-              <a:t>O6: Multi-metric benchmarking: RMSE, MAE, MAPE (Phase 3)</a:t>
-            </a:r>
-          </a:p>
-        </p:txBody>
-      </p:sp>
-      <p:sp>
-        <p:nvSpPr>
-          <p:cNvPr id="10" name="Rounded Rectangle 9"/>
+            <a:pPr algn="ctr">
+              <a:spcAft>
+                <a:spcPts val="400"/>
+              </a:spcAft>
+            </a:pPr>
+            <a:r>
+              <a:rPr sz="1000" b="0">
+                <a:solidFill>
+                  <a:srgbClr val="6B7785"/>
+                </a:solidFill>
+                <a:latin typeface="Calibri"/>
+              </a:rPr>
+              <a:t>Daily Points (≥500 required)</a:t>
+            </a:r>
+          </a:p>
+        </p:txBody>
+      </p:sp>
+      <p:sp>
+        <p:nvSpPr>
+          <p:cNvPr id="12" name="Rounded Rectangle 11"/>
           <p:cNvSpPr/>
           <p:nvPr/>
         </p:nvSpPr>
         <p:spPr>
           <a:xfrm>
-            <a:off x="6217920" y="1280160"/>
-            <a:ext cx="5513832" cy="4937760"/>
+            <a:off x="3291840" y="4617720"/>
+            <a:ext cx="2697480" cy="1234440"/>
           </a:xfrm>
           <a:prstGeom prst="roundRect">
             <a:avLst/>
@@ -4313,14 +4713,53 @@
       </p:sp>
       <p:sp>
         <p:nvSpPr>
-          <p:cNvPr id="11" name="TextBox 10"/>
+          <p:cNvPr id="13" name="TextBox 12"/>
           <p:cNvSpPr txBox="1"/>
           <p:nvPr/>
         </p:nvSpPr>
         <p:spPr>
           <a:xfrm>
-            <a:off x="6355080" y="1371600"/>
-            <a:ext cx="5239512" cy="320040"/>
+            <a:off x="3291840" y="4690872"/>
+            <a:ext cx="2697480" cy="641908"/>
+          </a:xfrm>
+          <a:prstGeom prst="rect">
+            <a:avLst/>
+          </a:prstGeom>
+          <a:noFill/>
+        </p:spPr>
+        <p:txBody>
+          <a:bodyPr wrap="square" anchor="ctr">
+            <a:spAutoFit/>
+          </a:bodyPr>
+          <a:lstStyle/>
+          <a:p>
+            <a:pPr algn="ctr">
+              <a:spcAft>
+                <a:spcPts val="400"/>
+              </a:spcAft>
+            </a:pPr>
+            <a:r>
+              <a:rPr sz="2200" b="1">
+                <a:solidFill>
+                  <a:srgbClr val="1F4E79"/>
+                </a:solidFill>
+                <a:latin typeface="Calibri"/>
+              </a:rPr>
+              <a:t>Open Data</a:t>
+            </a:r>
+          </a:p>
+        </p:txBody>
+      </p:sp>
+      <p:sp>
+        <p:nvSpPr>
+          <p:cNvPr id="14" name="TextBox 13"/>
+          <p:cNvSpPr txBox="1"/>
+          <p:nvPr/>
+        </p:nvSpPr>
+        <p:spPr>
+          <a:xfrm>
+            <a:off x="3291840" y="5296662"/>
+            <a:ext cx="2697480" cy="493776"/>
           </a:xfrm>
           <a:prstGeom prst="rect">
             <a:avLst/>
@@ -4333,33 +4772,117 @@
           </a:bodyPr>
           <a:lstStyle/>
           <a:p>
-            <a:pPr algn="l">
-              <a:spcAft>
-                <a:spcPts val="400"/>
-              </a:spcAft>
-            </a:pPr>
-            <a:r>
-              <a:rPr sz="1450" b="1">
+            <a:pPr algn="ctr">
+              <a:spcAft>
+                <a:spcPts val="400"/>
+              </a:spcAft>
+            </a:pPr>
+            <a:r>
+              <a:rPr sz="1000" b="0">
+                <a:solidFill>
+                  <a:srgbClr val="6B7785"/>
+                </a:solidFill>
+                <a:latin typeface="Calibri"/>
+              </a:rPr>
+              <a:t>Public Kaggle Dataset</a:t>
+            </a:r>
+          </a:p>
+        </p:txBody>
+      </p:sp>
+      <p:sp>
+        <p:nvSpPr>
+          <p:cNvPr id="15" name="Rounded Rectangle 14"/>
+          <p:cNvSpPr/>
+          <p:nvPr/>
+        </p:nvSpPr>
+        <p:spPr>
+          <a:xfrm>
+            <a:off x="6126480" y="4617720"/>
+            <a:ext cx="2697480" cy="1234440"/>
+          </a:xfrm>
+          <a:prstGeom prst="roundRect">
+            <a:avLst/>
+          </a:prstGeom>
+          <a:solidFill>
+            <a:srgbClr val="FFFFFF"/>
+          </a:solidFill>
+          <a:ln>
+            <a:solidFill>
+              <a:srgbClr val="D5DEE9"/>
+            </a:solidFill>
+          </a:ln>
+        </p:spPr>
+        <p:style>
+          <a:lnRef idx="1">
+            <a:schemeClr val="accent1"/>
+          </a:lnRef>
+          <a:fillRef idx="3">
+            <a:schemeClr val="accent1"/>
+          </a:fillRef>
+          <a:effectRef idx="2">
+            <a:schemeClr val="accent1"/>
+          </a:effectRef>
+          <a:fontRef idx="minor">
+            <a:schemeClr val="lt1"/>
+          </a:fontRef>
+        </p:style>
+        <p:txBody>
+          <a:bodyPr rtlCol="0" anchor="ctr"/>
+          <a:lstStyle/>
+          <a:p>
+            <a:pPr algn="ctr"/>
+          </a:p>
+        </p:txBody>
+      </p:sp>
+      <p:sp>
+        <p:nvSpPr>
+          <p:cNvPr id="16" name="TextBox 15"/>
+          <p:cNvSpPr txBox="1"/>
+          <p:nvPr/>
+        </p:nvSpPr>
+        <p:spPr>
+          <a:xfrm>
+            <a:off x="6126480" y="4690872"/>
+            <a:ext cx="2697480" cy="641908"/>
+          </a:xfrm>
+          <a:prstGeom prst="rect">
+            <a:avLst/>
+          </a:prstGeom>
+          <a:noFill/>
+        </p:spPr>
+        <p:txBody>
+          <a:bodyPr wrap="square" anchor="ctr">
+            <a:spAutoFit/>
+          </a:bodyPr>
+          <a:lstStyle/>
+          <a:p>
+            <a:pPr algn="ctr">
+              <a:spcAft>
+                <a:spcPts val="400"/>
+              </a:spcAft>
+            </a:pPr>
+            <a:r>
+              <a:rPr sz="2200" b="1">
                 <a:solidFill>
                   <a:srgbClr val="1F4E79"/>
                 </a:solidFill>
                 <a:latin typeface="Calibri"/>
               </a:rPr>
-              <a:t>Model Selection Justification (From EDA)</a:t>
-            </a:r>
-          </a:p>
-        </p:txBody>
-      </p:sp>
-      <p:sp>
-        <p:nvSpPr>
-          <p:cNvPr id="12" name="TextBox 11"/>
+              <a:t>Python Stack</a:t>
+            </a:r>
+          </a:p>
+        </p:txBody>
+      </p:sp>
+      <p:sp>
+        <p:nvSpPr>
+          <p:cNvPr id="17" name="TextBox 16"/>
           <p:cNvSpPr txBox="1"/>
           <p:nvPr/>
         </p:nvSpPr>
         <p:spPr>
           <a:xfrm>
-            <a:off x="6355080" y="1737360"/>
-            <a:ext cx="5239512" cy="4389120"/>
+            <a:off x="6126480" y="5296662"/>
+            <a:ext cx="2697480" cy="493776"/>
           </a:xfrm>
           <a:prstGeom prst="rect">
             <a:avLst/>
@@ -4372,83 +4895,142 @@
           </a:bodyPr>
           <a:lstStyle/>
           <a:p>
-            <a:pPr algn="l">
-              <a:spcAft>
-                <a:spcPts val="400"/>
-              </a:spcAft>
-            </a:pPr>
-            <a:r>
-              <a:rPr sz="1250" b="0">
-                <a:solidFill>
-                  <a:srgbClr val="1B2A3C"/>
-                </a:solidFill>
-                <a:latin typeface="Calibri"/>
-              </a:rPr>
-              <a:t>•  Strong Yearly Seasonality (Fs = 0.93) → Motivates SARIMA &amp; Holt-Winters</a:t>
-            </a:r>
-          </a:p>
-          <a:p>
-            <a:pPr algn="l">
-              <a:spcAft>
-                <a:spcPts val="400"/>
-              </a:spcAft>
-            </a:pPr>
-            <a:r>
-              <a:rPr sz="1250" b="0">
-                <a:solidFill>
-                  <a:srgbClr val="1B2A3C"/>
-                </a:solidFill>
-                <a:latin typeface="Calibri"/>
-              </a:rPr>
-              <a:t>•  Non-linear Multivariable Coupling → Motivates LSTM Networks</a:t>
-            </a:r>
-          </a:p>
-          <a:p>
-            <a:pPr algn="l">
-              <a:spcAft>
-                <a:spcPts val="400"/>
-              </a:spcAft>
-            </a:pPr>
-            <a:r>
-              <a:rPr sz="1250" b="0">
-                <a:solidFill>
-                  <a:srgbClr val="1B2A3C"/>
-                </a:solidFill>
-                <a:latin typeface="Calibri"/>
-              </a:rPr>
-              <a:t>•  Skewed Precipitation Values → Motivates Tree-based XGBoost with lag features</a:t>
-            </a:r>
-          </a:p>
-          <a:p>
-            <a:pPr algn="l">
-              <a:spcAft>
-                <a:spcPts val="400"/>
-              </a:spcAft>
-            </a:pPr>
-            <a:r>
-              <a:rPr sz="1250" b="0">
-                <a:solidFill>
-                  <a:srgbClr val="1B2A3C"/>
-                </a:solidFill>
-                <a:latin typeface="Calibri"/>
-              </a:rPr>
-              <a:t>•  Evaluation Design: Chronological train/test split (no shuffling) using RMSE, MAE, MAPE</a:t>
-            </a:r>
-          </a:p>
-          <a:p>
-            <a:pPr algn="l">
-              <a:spcAft>
-                <a:spcPts val="400"/>
-              </a:spcAft>
-            </a:pPr>
-            <a:r>
-              <a:rPr sz="1250" b="0">
-                <a:solidFill>
-                  <a:srgbClr val="1B2A3C"/>
-                </a:solidFill>
-                <a:latin typeface="Calibri"/>
-              </a:rPr>
-              <a:t>•  Strict Rule: No forecasting models are executed in Milestone 1</a:t>
+            <a:pPr algn="ctr">
+              <a:spcAft>
+                <a:spcPts val="400"/>
+              </a:spcAft>
+            </a:pPr>
+            <a:r>
+              <a:rPr sz="1000" b="0">
+                <a:solidFill>
+                  <a:srgbClr val="6B7785"/>
+                </a:solidFill>
+                <a:latin typeface="Calibri"/>
+              </a:rPr>
+              <a:t>pandas · matplotlib · seaborn · statsmodels</a:t>
+            </a:r>
+          </a:p>
+        </p:txBody>
+      </p:sp>
+      <p:sp>
+        <p:nvSpPr>
+          <p:cNvPr id="18" name="Rounded Rectangle 17"/>
+          <p:cNvSpPr/>
+          <p:nvPr/>
+        </p:nvSpPr>
+        <p:spPr>
+          <a:xfrm>
+            <a:off x="8961120" y="4617720"/>
+            <a:ext cx="2770632" cy="1234440"/>
+          </a:xfrm>
+          <a:prstGeom prst="roundRect">
+            <a:avLst/>
+          </a:prstGeom>
+          <a:solidFill>
+            <a:srgbClr val="FFFFFF"/>
+          </a:solidFill>
+          <a:ln>
+            <a:solidFill>
+              <a:srgbClr val="D5DEE9"/>
+            </a:solidFill>
+          </a:ln>
+        </p:spPr>
+        <p:style>
+          <a:lnRef idx="1">
+            <a:schemeClr val="accent1"/>
+          </a:lnRef>
+          <a:fillRef idx="3">
+            <a:schemeClr val="accent1"/>
+          </a:fillRef>
+          <a:effectRef idx="2">
+            <a:schemeClr val="accent1"/>
+          </a:effectRef>
+          <a:fontRef idx="minor">
+            <a:schemeClr val="lt1"/>
+          </a:fontRef>
+        </p:style>
+        <p:txBody>
+          <a:bodyPr rtlCol="0" anchor="ctr"/>
+          <a:lstStyle/>
+          <a:p>
+            <a:pPr algn="ctr"/>
+          </a:p>
+        </p:txBody>
+      </p:sp>
+      <p:sp>
+        <p:nvSpPr>
+          <p:cNvPr id="19" name="TextBox 18"/>
+          <p:cNvSpPr txBox="1"/>
+          <p:nvPr/>
+        </p:nvSpPr>
+        <p:spPr>
+          <a:xfrm>
+            <a:off x="8961120" y="4690872"/>
+            <a:ext cx="2770632" cy="641908"/>
+          </a:xfrm>
+          <a:prstGeom prst="rect">
+            <a:avLst/>
+          </a:prstGeom>
+          <a:noFill/>
+        </p:spPr>
+        <p:txBody>
+          <a:bodyPr wrap="square" anchor="ctr">
+            <a:spAutoFit/>
+          </a:bodyPr>
+          <a:lstStyle/>
+          <a:p>
+            <a:pPr algn="ctr">
+              <a:spcAft>
+                <a:spcPts val="400"/>
+              </a:spcAft>
+            </a:pPr>
+            <a:r>
+              <a:rPr sz="2200" b="1">
+                <a:solidFill>
+                  <a:srgbClr val="1F4E79"/>
+                </a:solidFill>
+                <a:latin typeface="Calibri"/>
+              </a:rPr>
+              <a:t>3-Phase Scope</a:t>
+            </a:r>
+          </a:p>
+        </p:txBody>
+      </p:sp>
+      <p:sp>
+        <p:nvSpPr>
+          <p:cNvPr id="20" name="TextBox 19"/>
+          <p:cNvSpPr txBox="1"/>
+          <p:nvPr/>
+        </p:nvSpPr>
+        <p:spPr>
+          <a:xfrm>
+            <a:off x="8961120" y="5296662"/>
+            <a:ext cx="2770632" cy="493776"/>
+          </a:xfrm>
+          <a:prstGeom prst="rect">
+            <a:avLst/>
+          </a:prstGeom>
+          <a:noFill/>
+        </p:spPr>
+        <p:txBody>
+          <a:bodyPr wrap="square" anchor="t">
+            <a:spAutoFit/>
+          </a:bodyPr>
+          <a:lstStyle/>
+          <a:p>
+            <a:pPr algn="ctr">
+              <a:spcAft>
+                <a:spcPts val="400"/>
+              </a:spcAft>
+            </a:pPr>
+            <a:r>
+              <a:rPr sz="1000" b="0">
+                <a:solidFill>
+                  <a:srgbClr val="6B7785"/>
+                </a:solidFill>
+                <a:latin typeface="Calibri"/>
+              </a:rPr>
+              <a:t>EDA → Classical → ML/DL</a:t>
             </a:r>
           </a:p>
         </p:txBody>
@@ -4599,7 +5181,7 @@
                 </a:solidFill>
                 <a:latin typeface="Calibri"/>
               </a:rPr>
-              <a:t>Conclusion &amp; Key References</a:t>
+              <a:t>Objectives &amp; Proposed Methodology</a:t>
             </a:r>
           </a:p>
         </p:txBody>
@@ -4677,7 +5259,7 @@
                 </a:solidFill>
                 <a:latin typeface="Calibri"/>
               </a:rPr>
-              <a:t>11 / 11</a:t>
+              <a:t>11 / 12</a:t>
             </a:r>
           </a:p>
         </p:txBody>
@@ -4691,7 +5273,7 @@
         <p:spPr>
           <a:xfrm>
             <a:off x="457200" y="1280160"/>
-            <a:ext cx="4114800" cy="4389120"/>
+            <a:ext cx="5486400" cy="4937760"/>
           </a:xfrm>
           <a:prstGeom prst="roundRect">
             <a:avLst/>
@@ -4736,7 +5318,7 @@
         <p:spPr>
           <a:xfrm>
             <a:off x="594360" y="1371600"/>
-            <a:ext cx="3840480" cy="320040"/>
+            <a:ext cx="5212080" cy="320040"/>
           </a:xfrm>
           <a:prstGeom prst="rect">
             <a:avLst/>
@@ -4755,13 +5337,13 @@
               </a:spcAft>
             </a:pPr>
             <a:r>
-              <a:rPr sz="1450" b="1">
+              <a:rPr sz="1400" b="1">
                 <a:solidFill>
                   <a:srgbClr val="1F4E79"/>
                 </a:solidFill>
                 <a:latin typeface="Calibri"/>
               </a:rPr>
-              <a:t>Milestone 1 Summary</a:t>
+              <a:t>Project Objectives Across Phases</a:t>
             </a:r>
           </a:p>
         </p:txBody>
@@ -4775,7 +5357,7 @@
         <p:spPr>
           <a:xfrm>
             <a:off x="594360" y="1737360"/>
-            <a:ext cx="3840480" cy="3840480"/>
+            <a:ext cx="5212080" cy="4389120"/>
           </a:xfrm>
           <a:prstGeom prst="rect">
             <a:avLst/>
@@ -4794,13 +5376,13 @@
               </a:spcAft>
             </a:pPr>
             <a:r>
-              <a:rPr sz="1250" b="0">
+              <a:rPr sz="1200" b="0">
                 <a:solidFill>
                   <a:srgbClr val="1B2A3C"/>
                 </a:solidFill>
                 <a:latin typeface="Calibri"/>
               </a:rPr>
-              <a:t>•  11,035 daily observations across 30 years ready for analysis.</a:t>
+              <a:t>O1: Perform dataset auditing, quality checks &amp; temporal validation (Phase 1 ✓)</a:t>
             </a:r>
           </a:p>
           <a:p>
@@ -4810,13 +5392,13 @@
               </a:spcAft>
             </a:pPr>
             <a:r>
-              <a:rPr sz="1250" b="0">
+              <a:rPr sz="1200" b="0">
                 <a:solidFill>
                   <a:srgbClr val="1B2A3C"/>
                 </a:solidFill>
                 <a:latin typeface="Calibri"/>
               </a:rPr>
-              <a:t>•  Data quality audited (&gt;99.7% completeness).</a:t>
+              <a:t>O2: Quantify trend, annual seasonality, and distribution extremes (Phase 1 ✓)</a:t>
             </a:r>
           </a:p>
           <a:p>
@@ -4826,13 +5408,13 @@
               </a:spcAft>
             </a:pPr>
             <a:r>
-              <a:rPr sz="1250" b="0">
+              <a:rPr sz="1200" b="0">
                 <a:solidFill>
                   <a:srgbClr val="1B2A3C"/>
                 </a:solidFill>
                 <a:latin typeface="Calibri"/>
               </a:rPr>
-              <a:t>•  Seasonal envelope and repeating annual cycle confirmed.</a:t>
+              <a:t>O3: Formulate problem scope and confirm technical feasibility (Phase 1 ✓)</a:t>
             </a:r>
           </a:p>
           <a:p>
@@ -4842,13 +5424,13 @@
               </a:spcAft>
             </a:pPr>
             <a:r>
-              <a:rPr sz="1250" b="0">
+              <a:rPr sz="1200" b="0">
                 <a:solidFill>
                   <a:srgbClr val="1B2A3C"/>
                 </a:solidFill>
                 <a:latin typeface="Calibri"/>
               </a:rPr>
-              <a:t>•  Feasible direction defined for classical and ML modeling.</a:t>
+              <a:t>O4: Implement Classical Baselines: ARIMA, SARIMA, Holt-Winters (Phase 2)</a:t>
             </a:r>
           </a:p>
           <a:p>
@@ -4858,13 +5440,45 @@
               </a:spcAft>
             </a:pPr>
             <a:r>
-              <a:rPr sz="1250" b="0">
+              <a:rPr sz="1200" b="0">
                 <a:solidFill>
                   <a:srgbClr val="1B2A3C"/>
                 </a:solidFill>
                 <a:latin typeface="Calibri"/>
               </a:rPr>
-              <a:t>•  No forecasting executed in Phase 1 (strictly compliant).</a:t>
+              <a:t>O5: Develop ML/DL Models: XGBoost, LSTM, Facebook Prophet (Phase 3)</a:t>
+            </a:r>
+          </a:p>
+          <a:p>
+            <a:pPr algn="l">
+              <a:spcAft>
+                <a:spcPts val="400"/>
+              </a:spcAft>
+            </a:pPr>
+            <a:r>
+              <a:rPr sz="1200" b="0">
+                <a:solidFill>
+                  <a:srgbClr val="1B2A3C"/>
+                </a:solidFill>
+                <a:latin typeface="Calibri"/>
+              </a:rPr>
+              <a:t>O6: Multi-metric benchmarking: RMSE, MAE, and MAPE (Phase 3)</a:t>
+            </a:r>
+          </a:p>
+          <a:p>
+            <a:pPr algn="l">
+              <a:spcAft>
+                <a:spcPts val="400"/>
+              </a:spcAft>
+            </a:pPr>
+            <a:r>
+              <a:rPr sz="1200" b="0">
+                <a:solidFill>
+                  <a:srgbClr val="1B2A3C"/>
+                </a:solidFill>
+                <a:latin typeface="Calibri"/>
+              </a:rPr>
+              <a:t>O7: Translate forecasts into stakeholder decision frameworks (Phase 3)</a:t>
             </a:r>
           </a:p>
         </p:txBody>
@@ -4877,8 +5491,8 @@
         </p:nvSpPr>
         <p:spPr>
           <a:xfrm>
-            <a:off x="4846320" y="1280160"/>
-            <a:ext cx="6858000" cy="4389120"/>
+            <a:off x="6217920" y="1280160"/>
+            <a:ext cx="5513832" cy="2834640"/>
           </a:xfrm>
           <a:prstGeom prst="roundRect">
             <a:avLst/>
@@ -4922,8 +5536,8 @@
         </p:nvSpPr>
         <p:spPr>
           <a:xfrm>
-            <a:off x="4983480" y="1371600"/>
-            <a:ext cx="6583680" cy="320040"/>
+            <a:off x="6355080" y="1371600"/>
+            <a:ext cx="5239512" cy="320040"/>
           </a:xfrm>
           <a:prstGeom prst="rect">
             <a:avLst/>
@@ -4942,13 +5556,13 @@
               </a:spcAft>
             </a:pPr>
             <a:r>
-              <a:rPr sz="1300" b="1">
+              <a:rPr sz="1400" b="1">
                 <a:solidFill>
                   <a:srgbClr val="1F4E79"/>
                 </a:solidFill>
                 <a:latin typeface="Calibri"/>
               </a:rPr>
-              <a:t>Academic References</a:t>
+              <a:t>Model Selection Justification (From Phase 1 EDA)</a:t>
             </a:r>
           </a:p>
         </p:txBody>
@@ -4961,8 +5575,8 @@
         </p:nvSpPr>
         <p:spPr>
           <a:xfrm>
-            <a:off x="4983480" y="1737360"/>
-            <a:ext cx="6583680" cy="3840480"/>
+            <a:off x="6355080" y="1737360"/>
+            <a:ext cx="5239512" cy="2286000"/>
           </a:xfrm>
           <a:prstGeom prst="rect">
             <a:avLst/>
@@ -4981,12 +5595,754 @@
               </a:spcAft>
             </a:pPr>
             <a:r>
-              <a:rPr sz="1100" b="0">
+              <a:rPr sz="1200" b="0">
                 <a:solidFill>
                   <a:srgbClr val="1B2A3C"/>
                 </a:solidFill>
                 <a:latin typeface="Calibri"/>
               </a:rPr>
+              <a:t>•  Strong Yearly Seasonality (Fs = 0.94) → Motivates seasonal models (SARIMA, Holt-Winters)</a:t>
+            </a:r>
+          </a:p>
+          <a:p>
+            <a:pPr algn="l">
+              <a:spcAft>
+                <a:spcPts val="400"/>
+              </a:spcAft>
+            </a:pPr>
+            <a:r>
+              <a:rPr sz="1200" b="0">
+                <a:solidFill>
+                  <a:srgbClr val="1B2A3C"/>
+                </a:solidFill>
+                <a:latin typeface="Calibri"/>
+              </a:rPr>
+              <a:t>•  Non-linear Multivariable Coupling → Motivates LSTM sequence models in Phase 3</a:t>
+            </a:r>
+          </a:p>
+          <a:p>
+            <a:pPr algn="l">
+              <a:spcAft>
+                <a:spcPts val="400"/>
+              </a:spcAft>
+            </a:pPr>
+            <a:r>
+              <a:rPr sz="1200" b="0">
+                <a:solidFill>
+                  <a:srgbClr val="1B2A3C"/>
+                </a:solidFill>
+                <a:latin typeface="Calibri"/>
+              </a:rPr>
+              <a:t>•  Skewed Precipitation Values → Motivates tree-based XGBoost on lag features in Phase 3</a:t>
+            </a:r>
+          </a:p>
+        </p:txBody>
+      </p:sp>
+      <p:sp>
+        <p:nvSpPr>
+          <p:cNvPr id="13" name="Rounded Rectangle 12"/>
+          <p:cNvSpPr/>
+          <p:nvPr/>
+        </p:nvSpPr>
+        <p:spPr>
+          <a:xfrm>
+            <a:off x="6217920" y="4251960"/>
+            <a:ext cx="5513832" cy="1965960"/>
+          </a:xfrm>
+          <a:prstGeom prst="roundRect">
+            <a:avLst/>
+          </a:prstGeom>
+          <a:solidFill>
+            <a:srgbClr val="FFFFFF"/>
+          </a:solidFill>
+          <a:ln>
+            <a:solidFill>
+              <a:srgbClr val="D5DEE9"/>
+            </a:solidFill>
+          </a:ln>
+        </p:spPr>
+        <p:style>
+          <a:lnRef idx="1">
+            <a:schemeClr val="accent1"/>
+          </a:lnRef>
+          <a:fillRef idx="3">
+            <a:schemeClr val="accent1"/>
+          </a:fillRef>
+          <a:effectRef idx="2">
+            <a:schemeClr val="accent1"/>
+          </a:effectRef>
+          <a:fontRef idx="minor">
+            <a:schemeClr val="lt1"/>
+          </a:fontRef>
+        </p:style>
+        <p:txBody>
+          <a:bodyPr rtlCol="0" anchor="ctr"/>
+          <a:lstStyle/>
+          <a:p>
+            <a:pPr algn="ctr"/>
+          </a:p>
+        </p:txBody>
+      </p:sp>
+      <p:sp>
+        <p:nvSpPr>
+          <p:cNvPr id="14" name="TextBox 13"/>
+          <p:cNvSpPr txBox="1"/>
+          <p:nvPr/>
+        </p:nvSpPr>
+        <p:spPr>
+          <a:xfrm>
+            <a:off x="6355080" y="4343400"/>
+            <a:ext cx="5239512" cy="320040"/>
+          </a:xfrm>
+          <a:prstGeom prst="rect">
+            <a:avLst/>
+          </a:prstGeom>
+          <a:noFill/>
+        </p:spPr>
+        <p:txBody>
+          <a:bodyPr wrap="square" anchor="t">
+            <a:spAutoFit/>
+          </a:bodyPr>
+          <a:lstStyle/>
+          <a:p>
+            <a:pPr algn="l">
+              <a:spcAft>
+                <a:spcPts val="400"/>
+              </a:spcAft>
+            </a:pPr>
+            <a:r>
+              <a:rPr sz="1350" b="1">
+                <a:solidFill>
+                  <a:srgbClr val="1F4E79"/>
+                </a:solidFill>
+                <a:latin typeface="Calibri"/>
+              </a:rPr>
+              <a:t>Planned Evaluation Protocol (Upcoming Phases)</a:t>
+            </a:r>
+          </a:p>
+        </p:txBody>
+      </p:sp>
+      <p:sp>
+        <p:nvSpPr>
+          <p:cNvPr id="15" name="TextBox 14"/>
+          <p:cNvSpPr txBox="1"/>
+          <p:nvPr/>
+        </p:nvSpPr>
+        <p:spPr>
+          <a:xfrm>
+            <a:off x="6355080" y="4709160"/>
+            <a:ext cx="5239512" cy="1417319"/>
+          </a:xfrm>
+          <a:prstGeom prst="rect">
+            <a:avLst/>
+          </a:prstGeom>
+          <a:noFill/>
+        </p:spPr>
+        <p:txBody>
+          <a:bodyPr wrap="square" anchor="t">
+            <a:spAutoFit/>
+          </a:bodyPr>
+          <a:lstStyle/>
+          <a:p>
+            <a:pPr algn="l">
+              <a:spcAft>
+                <a:spcPts val="400"/>
+              </a:spcAft>
+            </a:pPr>
+            <a:r>
+              <a:rPr sz="1150" b="0">
+                <a:solidFill>
+                  <a:srgbClr val="1B2A3C"/>
+                </a:solidFill>
+                <a:latin typeface="Calibri"/>
+              </a:rPr>
+              <a:t>•  Chronological Train / Validation / Test Split (Strictly no random shuffling)</a:t>
+            </a:r>
+          </a:p>
+          <a:p>
+            <a:pPr algn="l">
+              <a:spcAft>
+                <a:spcPts val="400"/>
+              </a:spcAft>
+            </a:pPr>
+            <a:r>
+              <a:rPr sz="1150" b="0">
+                <a:solidFill>
+                  <a:srgbClr val="1B2A3C"/>
+                </a:solidFill>
+                <a:latin typeface="Calibri"/>
+              </a:rPr>
+              <a:t>•  Error Metrics: RMSE (penalizes extremes), MAE (linear scale), MAPE</a:t>
+            </a:r>
+          </a:p>
+          <a:p>
+            <a:pPr algn="l">
+              <a:spcAft>
+                <a:spcPts val="400"/>
+              </a:spcAft>
+            </a:pPr>
+            <a:r>
+              <a:rPr sz="1150" b="0">
+                <a:solidFill>
+                  <a:srgbClr val="1B2A3C"/>
+                </a:solidFill>
+                <a:latin typeface="Calibri"/>
+              </a:rPr>
+              <a:t>•  Stationarity testing (ADF/KPSS) &amp; ACF/PACF diagnostics to be done in Phase 2</a:t>
+            </a:r>
+          </a:p>
+          <a:p>
+            <a:pPr algn="l">
+              <a:spcAft>
+                <a:spcPts val="400"/>
+              </a:spcAft>
+            </a:pPr>
+            <a:r>
+              <a:rPr sz="1150" b="0">
+                <a:solidFill>
+                  <a:srgbClr val="1B2A3C"/>
+                </a:solidFill>
+                <a:latin typeface="Calibri"/>
+              </a:rPr>
+              <a:t>•  Strict Compliance: No forecasting models are executed in Phase 1</a:t>
+            </a:r>
+          </a:p>
+        </p:txBody>
+      </p:sp>
+    </p:spTree>
+  </p:cSld>
+  <p:clrMapOvr>
+    <a:masterClrMapping/>
+  </p:clrMapOvr>
+</p:sld>
+</file>
+
+<file path=ppt/slides/slide12.xml><?xml version="1.0" encoding="utf-8"?>
+<p:sld xmlns:a="http://schemas.openxmlformats.org/drawingml/2006/main" xmlns:p="http://schemas.openxmlformats.org/presentationml/2006/main" xmlns:r="http://schemas.openxmlformats.org/officeDocument/2006/relationships">
+  <p:cSld>
+    <p:bg>
+      <p:bgPr>
+        <a:solidFill>
+          <a:srgbClr val="F6F9FC"/>
+        </a:solidFill>
+        <a:effectLst/>
+      </p:bgPr>
+    </p:bg>
+    <p:spTree>
+      <p:nvGrpSpPr>
+        <p:cNvPr id="1" name=""/>
+        <p:cNvGrpSpPr/>
+        <p:nvPr/>
+      </p:nvGrpSpPr>
+      <p:grpSpPr/>
+      <p:sp>
+        <p:nvSpPr>
+          <p:cNvPr id="2" name="Rectangle 1"/>
+          <p:cNvSpPr/>
+          <p:nvPr/>
+        </p:nvSpPr>
+        <p:spPr>
+          <a:xfrm>
+            <a:off x="0" y="0"/>
+            <a:ext cx="12191695" cy="960120"/>
+          </a:xfrm>
+          <a:prstGeom prst="rect">
+            <a:avLst/>
+          </a:prstGeom>
+          <a:solidFill>
+            <a:srgbClr val="0B1F3A"/>
+          </a:solidFill>
+          <a:ln>
+            <a:noFill/>
+          </a:ln>
+        </p:spPr>
+        <p:style>
+          <a:lnRef idx="1">
+            <a:schemeClr val="accent1"/>
+          </a:lnRef>
+          <a:fillRef idx="3">
+            <a:schemeClr val="accent1"/>
+          </a:fillRef>
+          <a:effectRef idx="2">
+            <a:schemeClr val="accent1"/>
+          </a:effectRef>
+          <a:fontRef idx="minor">
+            <a:schemeClr val="lt1"/>
+          </a:fontRef>
+        </p:style>
+        <p:txBody>
+          <a:bodyPr rtlCol="0" anchor="ctr"/>
+          <a:lstStyle/>
+          <a:p>
+            <a:pPr algn="ctr"/>
+          </a:p>
+        </p:txBody>
+      </p:sp>
+      <p:sp>
+        <p:nvSpPr>
+          <p:cNvPr id="3" name="Rectangle 2"/>
+          <p:cNvSpPr/>
+          <p:nvPr/>
+        </p:nvSpPr>
+        <p:spPr>
+          <a:xfrm>
+            <a:off x="0" y="960120"/>
+            <a:ext cx="12191695" cy="45720"/>
+          </a:xfrm>
+          <a:prstGeom prst="rect">
+            <a:avLst/>
+          </a:prstGeom>
+          <a:solidFill>
+            <a:srgbClr val="F28C28"/>
+          </a:solidFill>
+          <a:ln>
+            <a:noFill/>
+          </a:ln>
+        </p:spPr>
+        <p:style>
+          <a:lnRef idx="1">
+            <a:schemeClr val="accent1"/>
+          </a:lnRef>
+          <a:fillRef idx="3">
+            <a:schemeClr val="accent1"/>
+          </a:fillRef>
+          <a:effectRef idx="2">
+            <a:schemeClr val="accent1"/>
+          </a:effectRef>
+          <a:fontRef idx="minor">
+            <a:schemeClr val="lt1"/>
+          </a:fontRef>
+        </p:style>
+        <p:txBody>
+          <a:bodyPr rtlCol="0" anchor="ctr"/>
+          <a:lstStyle/>
+          <a:p>
+            <a:pPr algn="ctr"/>
+          </a:p>
+        </p:txBody>
+      </p:sp>
+      <p:sp>
+        <p:nvSpPr>
+          <p:cNvPr id="4" name="TextBox 3"/>
+          <p:cNvSpPr txBox="1"/>
+          <p:nvPr/>
+        </p:nvSpPr>
+        <p:spPr>
+          <a:xfrm>
+            <a:off x="457200" y="137160"/>
+            <a:ext cx="10058400" cy="685800"/>
+          </a:xfrm>
+          <a:prstGeom prst="rect">
+            <a:avLst/>
+          </a:prstGeom>
+          <a:noFill/>
+        </p:spPr>
+        <p:txBody>
+          <a:bodyPr wrap="square" anchor="ctr">
+            <a:spAutoFit/>
+          </a:bodyPr>
+          <a:lstStyle/>
+          <a:p>
+            <a:pPr algn="l">
+              <a:spcAft>
+                <a:spcPts val="400"/>
+              </a:spcAft>
+            </a:pPr>
+            <a:r>
+              <a:rPr sz="2300" b="1">
+                <a:solidFill>
+                  <a:srgbClr val="FFFFFF"/>
+                </a:solidFill>
+                <a:latin typeface="Calibri"/>
+              </a:rPr>
+              <a:t>Conclusion &amp; Academic References</a:t>
+            </a:r>
+          </a:p>
+        </p:txBody>
+      </p:sp>
+      <p:sp>
+        <p:nvSpPr>
+          <p:cNvPr id="5" name="TextBox 4"/>
+          <p:cNvSpPr txBox="1"/>
+          <p:nvPr/>
+        </p:nvSpPr>
+        <p:spPr>
+          <a:xfrm>
+            <a:off x="457200" y="6492240"/>
+            <a:ext cx="8229600" cy="274320"/>
+          </a:xfrm>
+          <a:prstGeom prst="rect">
+            <a:avLst/>
+          </a:prstGeom>
+          <a:noFill/>
+        </p:spPr>
+        <p:txBody>
+          <a:bodyPr wrap="square" anchor="t">
+            <a:spAutoFit/>
+          </a:bodyPr>
+          <a:lstStyle/>
+          <a:p>
+            <a:pPr algn="l">
+              <a:spcAft>
+                <a:spcPts val="400"/>
+              </a:spcAft>
+            </a:pPr>
+            <a:r>
+              <a:rPr sz="900" b="0">
+                <a:solidFill>
+                  <a:srgbClr val="6B7785"/>
+                </a:solidFill>
+                <a:latin typeface="Calibri"/>
+              </a:rPr>
+              <a:t>DELHI WEATHER ANALYTICS (1996–2026) | Milestone 1 Synopsis</a:t>
+            </a:r>
+          </a:p>
+        </p:txBody>
+      </p:sp>
+      <p:sp>
+        <p:nvSpPr>
+          <p:cNvPr id="6" name="TextBox 5"/>
+          <p:cNvSpPr txBox="1"/>
+          <p:nvPr/>
+        </p:nvSpPr>
+        <p:spPr>
+          <a:xfrm>
+            <a:off x="10789920" y="6492240"/>
+            <a:ext cx="1005840" cy="274320"/>
+          </a:xfrm>
+          <a:prstGeom prst="rect">
+            <a:avLst/>
+          </a:prstGeom>
+          <a:noFill/>
+        </p:spPr>
+        <p:txBody>
+          <a:bodyPr wrap="square" anchor="t">
+            <a:spAutoFit/>
+          </a:bodyPr>
+          <a:lstStyle/>
+          <a:p>
+            <a:pPr algn="r">
+              <a:spcAft>
+                <a:spcPts val="400"/>
+              </a:spcAft>
+            </a:pPr>
+            <a:r>
+              <a:rPr sz="900" b="0">
+                <a:solidFill>
+                  <a:srgbClr val="6B7785"/>
+                </a:solidFill>
+                <a:latin typeface="Calibri"/>
+              </a:rPr>
+              <a:t>12 / 12</a:t>
+            </a:r>
+          </a:p>
+        </p:txBody>
+      </p:sp>
+      <p:sp>
+        <p:nvSpPr>
+          <p:cNvPr id="7" name="Rounded Rectangle 6"/>
+          <p:cNvSpPr/>
+          <p:nvPr/>
+        </p:nvSpPr>
+        <p:spPr>
+          <a:xfrm>
+            <a:off x="457200" y="1280160"/>
+            <a:ext cx="4023360" cy="4389120"/>
+          </a:xfrm>
+          <a:prstGeom prst="roundRect">
+            <a:avLst/>
+          </a:prstGeom>
+          <a:solidFill>
+            <a:srgbClr val="FFFFFF"/>
+          </a:solidFill>
+          <a:ln>
+            <a:solidFill>
+              <a:srgbClr val="D5DEE9"/>
+            </a:solidFill>
+          </a:ln>
+        </p:spPr>
+        <p:style>
+          <a:lnRef idx="1">
+            <a:schemeClr val="accent1"/>
+          </a:lnRef>
+          <a:fillRef idx="3">
+            <a:schemeClr val="accent1"/>
+          </a:fillRef>
+          <a:effectRef idx="2">
+            <a:schemeClr val="accent1"/>
+          </a:effectRef>
+          <a:fontRef idx="minor">
+            <a:schemeClr val="lt1"/>
+          </a:fontRef>
+        </p:style>
+        <p:txBody>
+          <a:bodyPr rtlCol="0" anchor="ctr"/>
+          <a:lstStyle/>
+          <a:p>
+            <a:pPr algn="ctr"/>
+          </a:p>
+        </p:txBody>
+      </p:sp>
+      <p:sp>
+        <p:nvSpPr>
+          <p:cNvPr id="8" name="TextBox 7"/>
+          <p:cNvSpPr txBox="1"/>
+          <p:nvPr/>
+        </p:nvSpPr>
+        <p:spPr>
+          <a:xfrm>
+            <a:off x="594360" y="1371600"/>
+            <a:ext cx="3749040" cy="320040"/>
+          </a:xfrm>
+          <a:prstGeom prst="rect">
+            <a:avLst/>
+          </a:prstGeom>
+          <a:noFill/>
+        </p:spPr>
+        <p:txBody>
+          <a:bodyPr wrap="square" anchor="t">
+            <a:spAutoFit/>
+          </a:bodyPr>
+          <a:lstStyle/>
+          <a:p>
+            <a:pPr algn="l">
+              <a:spcAft>
+                <a:spcPts val="400"/>
+              </a:spcAft>
+            </a:pPr>
+            <a:r>
+              <a:rPr sz="1400" b="1">
+                <a:solidFill>
+                  <a:srgbClr val="1F4E79"/>
+                </a:solidFill>
+                <a:latin typeface="Calibri"/>
+              </a:rPr>
+              <a:t>Milestone 1 Summary</a:t>
+            </a:r>
+          </a:p>
+        </p:txBody>
+      </p:sp>
+      <p:sp>
+        <p:nvSpPr>
+          <p:cNvPr id="9" name="TextBox 8"/>
+          <p:cNvSpPr txBox="1"/>
+          <p:nvPr/>
+        </p:nvSpPr>
+        <p:spPr>
+          <a:xfrm>
+            <a:off x="594360" y="1737360"/>
+            <a:ext cx="3749040" cy="3840480"/>
+          </a:xfrm>
+          <a:prstGeom prst="rect">
+            <a:avLst/>
+          </a:prstGeom>
+          <a:noFill/>
+        </p:spPr>
+        <p:txBody>
+          <a:bodyPr wrap="square" anchor="t">
+            <a:spAutoFit/>
+          </a:bodyPr>
+          <a:lstStyle/>
+          <a:p>
+            <a:pPr algn="l">
+              <a:spcAft>
+                <a:spcPts val="400"/>
+              </a:spcAft>
+            </a:pPr>
+            <a:r>
+              <a:rPr sz="1200" b="0">
+                <a:solidFill>
+                  <a:srgbClr val="1B2A3C"/>
+                </a:solidFill>
+                <a:latin typeface="Calibri"/>
+              </a:rPr>
+              <a:t>•  Curated 11,035 daily observations across 30 years (1996–2026).</a:t>
+            </a:r>
+          </a:p>
+          <a:p>
+            <a:pPr algn="l">
+              <a:spcAft>
+                <a:spcPts val="400"/>
+              </a:spcAft>
+            </a:pPr>
+            <a:r>
+              <a:rPr sz="1200" b="0">
+                <a:solidFill>
+                  <a:srgbClr val="1B2A3C"/>
+                </a:solidFill>
+                <a:latin typeface="Calibri"/>
+              </a:rPr>
+              <a:t>•  Data quality audited: 0 duplicate timestamps, 100% temporal continuity.</a:t>
+            </a:r>
+          </a:p>
+          <a:p>
+            <a:pPr algn="l">
+              <a:spcAft>
+                <a:spcPts val="400"/>
+              </a:spcAft>
+            </a:pPr>
+            <a:r>
+              <a:rPr sz="1200" b="0">
+                <a:solidFill>
+                  <a:srgbClr val="1B2A3C"/>
+                </a:solidFill>
+                <a:latin typeface="Calibri"/>
+              </a:rPr>
+              <a:t>•  Strong yearly seasonal pattern identified (Fs = 0.93).</a:t>
+            </a:r>
+          </a:p>
+          <a:p>
+            <a:pPr algn="l">
+              <a:spcAft>
+                <a:spcPts val="400"/>
+              </a:spcAft>
+            </a:pPr>
+            <a:r>
+              <a:rPr sz="1200" b="0">
+                <a:solidFill>
+                  <a:srgbClr val="1B2A3C"/>
+                </a:solidFill>
+                <a:latin typeface="Calibri"/>
+              </a:rPr>
+              <a:t>•  Technical feasibility confirmed across data volume and Python tooling.</a:t>
+            </a:r>
+          </a:p>
+          <a:p>
+            <a:pPr algn="l">
+              <a:spcAft>
+                <a:spcPts val="400"/>
+              </a:spcAft>
+            </a:pPr>
+            <a:r>
+              <a:rPr sz="1200" b="0">
+                <a:solidFill>
+                  <a:srgbClr val="1B2A3C"/>
+                </a:solidFill>
+                <a:latin typeface="Calibri"/>
+              </a:rPr>
+              <a:t>•  Next Steps: Phase 2 will execute stationarity tests and classical models.</a:t>
+            </a:r>
+          </a:p>
+        </p:txBody>
+      </p:sp>
+      <p:sp>
+        <p:nvSpPr>
+          <p:cNvPr id="10" name="Rounded Rectangle 9"/>
+          <p:cNvSpPr/>
+          <p:nvPr/>
+        </p:nvSpPr>
+        <p:spPr>
+          <a:xfrm>
+            <a:off x="4663440" y="1280160"/>
+            <a:ext cx="7040880" cy="4389120"/>
+          </a:xfrm>
+          <a:prstGeom prst="roundRect">
+            <a:avLst/>
+          </a:prstGeom>
+          <a:solidFill>
+            <a:srgbClr val="FFFFFF"/>
+          </a:solidFill>
+          <a:ln>
+            <a:solidFill>
+              <a:srgbClr val="D5DEE9"/>
+            </a:solidFill>
+          </a:ln>
+        </p:spPr>
+        <p:style>
+          <a:lnRef idx="1">
+            <a:schemeClr val="accent1"/>
+          </a:lnRef>
+          <a:fillRef idx="3">
+            <a:schemeClr val="accent1"/>
+          </a:fillRef>
+          <a:effectRef idx="2">
+            <a:schemeClr val="accent1"/>
+          </a:effectRef>
+          <a:fontRef idx="minor">
+            <a:schemeClr val="lt1"/>
+          </a:fontRef>
+        </p:style>
+        <p:txBody>
+          <a:bodyPr rtlCol="0" anchor="ctr"/>
+          <a:lstStyle/>
+          <a:p>
+            <a:pPr algn="ctr"/>
+          </a:p>
+        </p:txBody>
+      </p:sp>
+      <p:sp>
+        <p:nvSpPr>
+          <p:cNvPr id="11" name="TextBox 10"/>
+          <p:cNvSpPr txBox="1"/>
+          <p:nvPr/>
+        </p:nvSpPr>
+        <p:spPr>
+          <a:xfrm>
+            <a:off x="4800600" y="1371600"/>
+            <a:ext cx="6766560" cy="320040"/>
+          </a:xfrm>
+          <a:prstGeom prst="rect">
+            <a:avLst/>
+          </a:prstGeom>
+          <a:noFill/>
+        </p:spPr>
+        <p:txBody>
+          <a:bodyPr wrap="square" anchor="t">
+            <a:spAutoFit/>
+          </a:bodyPr>
+          <a:lstStyle/>
+          <a:p>
+            <a:pPr algn="l">
+              <a:spcAft>
+                <a:spcPts val="400"/>
+              </a:spcAft>
+            </a:pPr>
+            <a:r>
+              <a:rPr sz="1250" b="1">
+                <a:solidFill>
+                  <a:srgbClr val="1F4E79"/>
+                </a:solidFill>
+                <a:latin typeface="Calibri"/>
+              </a:rPr>
+              <a:t>Academic &amp; Peer-Reviewed References</a:t>
+            </a:r>
+          </a:p>
+        </p:txBody>
+      </p:sp>
+      <p:sp>
+        <p:nvSpPr>
+          <p:cNvPr id="12" name="TextBox 11"/>
+          <p:cNvSpPr txBox="1"/>
+          <p:nvPr/>
+        </p:nvSpPr>
+        <p:spPr>
+          <a:xfrm>
+            <a:off x="4800600" y="1737360"/>
+            <a:ext cx="6766560" cy="3840480"/>
+          </a:xfrm>
+          <a:prstGeom prst="rect">
+            <a:avLst/>
+          </a:prstGeom>
+          <a:noFill/>
+        </p:spPr>
+        <p:txBody>
+          <a:bodyPr wrap="square" anchor="t">
+            <a:spAutoFit/>
+          </a:bodyPr>
+          <a:lstStyle/>
+          <a:p>
+            <a:pPr algn="l">
+              <a:spcAft>
+                <a:spcPts val="400"/>
+              </a:spcAft>
+            </a:pPr>
+            <a:r>
+              <a:rPr sz="1050" b="0">
+                <a:solidFill>
+                  <a:srgbClr val="1B2A3C"/>
+                </a:solidFill>
+                <a:latin typeface="Calibri"/>
+              </a:rPr>
               <a:t>•  Hyndman &amp; Athanasopoulos (2021). Forecasting: Principles and Practice (3rd ed.). OTexts.</a:t>
             </a:r>
           </a:p>
@@ -4997,7 +6353,7 @@
               </a:spcAft>
             </a:pPr>
             <a:r>
-              <a:rPr sz="1100" b="0">
+              <a:rPr sz="1050" b="0">
                 <a:solidFill>
                   <a:srgbClr val="1B2A3C"/>
                 </a:solidFill>
@@ -5013,7 +6369,7 @@
               </a:spcAft>
             </a:pPr>
             <a:r>
-              <a:rPr sz="1100" b="0">
+              <a:rPr sz="1050" b="0">
                 <a:solidFill>
                   <a:srgbClr val="1B2A3C"/>
                 </a:solidFill>
@@ -5029,7 +6385,7 @@
               </a:spcAft>
             </a:pPr>
             <a:r>
-              <a:rPr sz="1100" b="0">
+              <a:rPr sz="1050" b="0">
                 <a:solidFill>
                   <a:srgbClr val="1B2A3C"/>
                 </a:solidFill>
@@ -5045,7 +6401,7 @@
               </a:spcAft>
             </a:pPr>
             <a:r>
-              <a:rPr sz="1100" b="0">
+              <a:rPr sz="1050" b="0">
                 <a:solidFill>
                   <a:srgbClr val="1B2A3C"/>
                 </a:solidFill>
@@ -5061,7 +6417,7 @@
               </a:spcAft>
             </a:pPr>
             <a:r>
-              <a:rPr sz="1100" b="0">
+              <a:rPr sz="1050" b="0">
                 <a:solidFill>
                   <a:srgbClr val="1B2A3C"/>
                 </a:solidFill>
@@ -5077,12 +6433,28 @@
               </a:spcAft>
             </a:pPr>
             <a:r>
-              <a:rPr sz="1100" b="0">
+              <a:rPr sz="1050" b="0">
                 <a:solidFill>
                   <a:srgbClr val="1B2A3C"/>
                 </a:solidFill>
                 <a:latin typeface="Calibri"/>
               </a:rPr>
+              <a:t>•  Bauer, Thorpe &amp; Brunet (2015). The quiet revolution of numerical weather prediction. Nature.</a:t>
+            </a:r>
+          </a:p>
+          <a:p>
+            <a:pPr algn="l">
+              <a:spcAft>
+                <a:spcPts val="400"/>
+              </a:spcAft>
+            </a:pPr>
+            <a:r>
+              <a:rPr sz="1050" b="0">
+                <a:solidFill>
+                  <a:srgbClr val="1B2A3C"/>
+                </a:solidFill>
+                <a:latin typeface="Calibri"/>
+              </a:rPr>
               <a:t>•  Rasp et al. (2020). WeatherBench: Benchmark for Data-Driven Weather Forecasting. JAMES.</a:t>
             </a:r>
           </a:p>
@@ -5093,13 +6465,13 @@
               </a:spcAft>
             </a:pPr>
             <a:r>
-              <a:rPr sz="1100" b="0">
+              <a:rPr sz="1050" b="0">
                 <a:solidFill>
                   <a:srgbClr val="1B2A3C"/>
                 </a:solidFill>
                 <a:latin typeface="Calibri"/>
               </a:rPr>
-              <a:t>•  Dataset: Kaggle - Indian Weather Dataset (1996–2026) (kaggle.com/datasets/sandeepgupta09/indian-weather-dataset-1996-2026)</a:t>
+              <a:t>•  Dataset: Kaggle - sandeepgupta09 / Indian Weather Dataset 1996-2026 (kaggle.com/datasets/sandeepgupta09/indian-weather-dataset-1996-2026)</a:t>
             </a:r>
           </a:p>
         </p:txBody>
@@ -5181,7 +6553,7 @@
                 </a:solidFill>
                 <a:latin typeface="Calibri"/>
               </a:rPr>
-              <a:t>Next Steps (Phase 2): Differencing, stationarity tests, and classical ARIMA/SARIMA &amp; Holt-Winters implementation.</a:t>
+              <a:t>NEXT STEPS (Phase 2): Implement data preprocessing, stationarity checks (ADF/KPSS), and classical ARIMA/SARIMA &amp; Holt-Winters models.</a:t>
             </a:r>
           </a:p>
         </p:txBody>
@@ -5410,7 +6782,7 @@
                 </a:solidFill>
                 <a:latin typeface="Calibri"/>
               </a:rPr>
-              <a:t>2 / 11</a:t>
+              <a:t>2 / 12</a:t>
             </a:r>
           </a:p>
         </p:txBody>
@@ -5494,7 +6866,7 @@
                 </a:solidFill>
                 <a:latin typeface="Calibri"/>
               </a:rPr>
-              <a:t>Time Series Fundamentals</a:t>
+              <a:t>Time Series Analysis in Brief</a:t>
             </a:r>
           </a:p>
         </p:txBody>
@@ -5533,7 +6905,7 @@
                 </a:solidFill>
                 <a:latin typeface="Calibri"/>
               </a:rPr>
-              <a:t>•  Temporal Ordering: Data points recorded chronologically; order matters.</a:t>
+              <a:t>•  Temporal Ordering: Data points recorded sequentially across time where temporal dependency matters.</a:t>
             </a:r>
           </a:p>
           <a:p>
@@ -5549,7 +6921,7 @@
                 </a:solidFill>
                 <a:latin typeface="Calibri"/>
               </a:rPr>
-              <a:t>•  Four Components: Trend, Seasonality, Cyclic, and Irregular Residual.</a:t>
+              <a:t>•  Four Components: Trend (long-term drift), Seasonality (periodic cycles), Cyclic variations, and Residual noise.</a:t>
             </a:r>
           </a:p>
           <a:p>
@@ -5565,7 +6937,7 @@
                 </a:solidFill>
                 <a:latin typeface="Calibri"/>
               </a:rPr>
-              <a:t>•  Component Decomposition: Essential before choosing any forecasting model.</a:t>
+              <a:t>•  Component Decomposition: Decomposing temporal structure is required before any forecasting model is selected.</a:t>
             </a:r>
           </a:p>
           <a:p>
@@ -5581,7 +6953,23 @@
                 </a:solidFill>
                 <a:latin typeface="Calibri"/>
               </a:rPr>
-              <a:t>•  Applications: Energy consumption, environment, agriculture, and healthcare.</a:t>
+              <a:t>•  Cross-Domain Relevance: Essential in Energy load management, Climatology, Agriculture, and Public Health.</a:t>
+            </a:r>
+          </a:p>
+          <a:p>
+            <a:pPr algn="l">
+              <a:spcAft>
+                <a:spcPts val="400"/>
+              </a:spcAft>
+            </a:pPr>
+            <a:r>
+              <a:rPr sz="1300" b="0">
+                <a:solidFill>
+                  <a:srgbClr val="1B2A3C"/>
+                </a:solidFill>
+                <a:latin typeface="Calibri"/>
+              </a:rPr>
+              <a:t>•  Phase 1 Objective: Understand empirical properties before model training in later phases.</a:t>
             </a:r>
           </a:p>
         </p:txBody>
@@ -5665,7 +7053,7 @@
                 </a:solidFill>
                 <a:latin typeface="Calibri"/>
               </a:rPr>
-              <a:t>Why Delhi Weather?</a:t>
+              <a:t>Why Delhi Weather Dynamics?</a:t>
             </a:r>
           </a:p>
         </p:txBody>
@@ -5704,7 +7092,7 @@
                 </a:solidFill>
                 <a:latin typeface="Calibri"/>
               </a:rPr>
-              <a:t>•  Severe Climate Extremes: Hot summers (&gt;45°C), monsoons, and cold winters.</a:t>
+              <a:t>•  Subtropical Continental Extremes: Delhi experiences severe summer heatwaves (&gt;45°C), monsoons, and winter cold snaps.</a:t>
             </a:r>
           </a:p>
           <a:p>
@@ -5720,7 +7108,7 @@
                 </a:solidFill>
                 <a:latin typeface="Calibri"/>
               </a:rPr>
-              <a:t>•  Grid &amp; Planning Impact: Drives peak electricity load and municipal flood management.</a:t>
+              <a:t>•  Urban Energy &amp; Grid Management: Extreme heat directly triggers summer peak electricity demand.</a:t>
             </a:r>
           </a:p>
           <a:p>
@@ -5736,7 +7124,7 @@
                 </a:solidFill>
                 <a:latin typeface="Calibri"/>
               </a:rPr>
-              <a:t>•  30-Year Longitudinal Archive: 1996–2026 dataset provides repeated seasonal cycles.</a:t>
+              <a:t>•  Hydrological &amp; Drainage Planning: Concentrated monsoon downpours demand evidence-based urban stormwater planning.</a:t>
             </a:r>
           </a:p>
           <a:p>
@@ -5752,7 +7140,23 @@
                 </a:solidFill>
                 <a:latin typeface="Calibri"/>
               </a:rPr>
-              <a:t>•  Feasible &amp; Open: Public dataset ready for multi-phase exploration.</a:t>
+              <a:t>•  Over 30 Years of Observations: Longitudinal observations from 1 January 1996 to 18 March 2026.</a:t>
+            </a:r>
+          </a:p>
+          <a:p>
+            <a:pPr algn="l">
+              <a:spcAft>
+                <a:spcPts val="400"/>
+              </a:spcAft>
+            </a:pPr>
+            <a:r>
+              <a:rPr sz="1300" b="0">
+                <a:solidFill>
+                  <a:srgbClr val="1B2A3C"/>
+                </a:solidFill>
+                <a:latin typeface="Calibri"/>
+              </a:rPr>
+              <a:t>•  Open Benchmark: Publicly accessible Kaggle dataset ensuring scientific reproducibility.</a:t>
             </a:r>
           </a:p>
         </p:txBody>
@@ -5981,7 +7385,7 @@
                 </a:solidFill>
                 <a:latin typeface="Calibri"/>
               </a:rPr>
-              <a:t>3 / 11</a:t>
+              <a:t>3 / 12</a:t>
             </a:r>
           </a:p>
         </p:txBody>
@@ -6063,7 +7467,7 @@
                 </a:solidFill>
                 <a:latin typeface="Calibri"/>
               </a:rPr>
-              <a:t>How do temperature and precipitation in Delhi evolve over 30 years across seasonal and trend components, and what empirical properties govern the choice of future forecasting models?</a:t>
+              <a:t>How do temperature, precipitation, and atmospheric variables in Delhi evolve across seasonal and multi-decadal horizons (1996–2026), and what empirical properties govern the choice of future forecasting models?</a:t>
             </a:r>
           </a:p>
         </p:txBody>
@@ -6186,7 +7590,7 @@
                 </a:solidFill>
                 <a:latin typeface="Calibri"/>
               </a:rPr>
-              <a:t>•  Pattern identification (Phase 1)</a:t>
+              <a:t>•  Pattern &amp; Seasonality Discovery (Phase 1)</a:t>
             </a:r>
           </a:p>
           <a:p>
@@ -6202,7 +7606,7 @@
                 </a:solidFill>
                 <a:latin typeface="Calibri"/>
               </a:rPr>
-              <a:t>•  Extreme-event exploration</a:t>
+              <a:t>•  Extreme event &amp; anomaly exploration</a:t>
             </a:r>
           </a:p>
           <a:p>
@@ -6218,7 +7622,7 @@
                 </a:solidFill>
                 <a:latin typeface="Calibri"/>
               </a:rPr>
-              <a:t>•  Temperature-rainfall relation</a:t>
+              <a:t>•  Temperature-rainfall association</a:t>
             </a:r>
           </a:p>
           <a:p>
@@ -6234,7 +7638,7 @@
                 </a:solidFill>
                 <a:latin typeface="Calibri"/>
               </a:rPr>
-              <a:t>•  Future model scoping</a:t>
+              <a:t>•  Scoping models for Phases 2 &amp; 3</a:t>
             </a:r>
           </a:p>
         </p:txBody>
@@ -6318,7 +7722,7 @@
                 </a:solidFill>
                 <a:latin typeface="Calibri"/>
               </a:rPr>
-              <a:t>Stakeholders</a:t>
+              <a:t>Target Stakeholders</a:t>
             </a:r>
           </a:p>
         </p:txBody>
@@ -6357,7 +7761,7 @@
                 </a:solidFill>
                 <a:latin typeface="Calibri"/>
               </a:rPr>
-              <a:t>•  Power distribution utilities</a:t>
+              <a:t>•  Power utilities (grid peak load)</a:t>
             </a:r>
           </a:p>
           <a:p>
@@ -6373,7 +7777,7 @@
                 </a:solidFill>
                 <a:latin typeface="Calibri"/>
               </a:rPr>
-              <a:t>•  City disaster planners</a:t>
+              <a:t>•  City disaster management authorities</a:t>
             </a:r>
           </a:p>
           <a:p>
@@ -6389,7 +7793,7 @@
                 </a:solidFill>
                 <a:latin typeface="Calibri"/>
               </a:rPr>
-              <a:t>•  Agricultural planners</a:t>
+              <a:t>•  Agronomy &amp; farming agencies</a:t>
             </a:r>
           </a:p>
           <a:p>
@@ -6405,7 +7809,7 @@
                 </a:solidFill>
                 <a:latin typeface="Calibri"/>
               </a:rPr>
-              <a:t>•  Public health agencies</a:t>
+              <a:t>•  Public health advisory departments</a:t>
             </a:r>
           </a:p>
         </p:txBody>
@@ -6528,7 +7932,7 @@
                 </a:solidFill>
                 <a:latin typeface="Calibri"/>
               </a:rPr>
-              <a:t>•  Seasonal grid resource planning</a:t>
+              <a:t>•  Seasonal energy resource allocation</a:t>
             </a:r>
           </a:p>
           <a:p>
@@ -6544,7 +7948,7 @@
                 </a:solidFill>
                 <a:latin typeface="Calibri"/>
               </a:rPr>
-              <a:t>•  Heatwave early advisories</a:t>
+              <a:t>•  Heatwave early warning advisories</a:t>
             </a:r>
           </a:p>
           <a:p>
@@ -6560,7 +7964,7 @@
                 </a:solidFill>
                 <a:latin typeface="Calibri"/>
               </a:rPr>
-              <a:t>•  Drainage scheduling</a:t>
+              <a:t>•  Municipal stormwater management</a:t>
             </a:r>
           </a:p>
           <a:p>
@@ -6576,7 +7980,7 @@
                 </a:solidFill>
                 <a:latin typeface="Calibri"/>
               </a:rPr>
-              <a:t>•  Forecasting model selection</a:t>
+              <a:t>•  Selection of appropriate forecasting models</a:t>
             </a:r>
           </a:p>
         </p:txBody>
@@ -6805,7 +8209,7 @@
                 </a:solidFill>
                 <a:latin typeface="Calibri"/>
               </a:rPr>
-              <a:t>4 / 11</a:t>
+              <a:t>4 / 12</a:t>
             </a:r>
           </a:p>
         </p:txBody>
@@ -6820,7 +8224,7 @@
         </p:nvGraphicFramePr>
         <p:xfrm>
           <a:off x="457200" y="1234440"/>
-          <a:ext cx="5669280" cy="2084832"/>
+          <a:ext cx="5669280" cy="2560320"/>
         </p:xfrm>
         <a:graphic>
           <a:graphicData uri="http://schemas.openxmlformats.org/drawingml/2006/table">
@@ -6829,20 +8233,20 @@
                 <a:tableStyleId>{5C22544A-7EE6-4342-B048-85BDC9FD1C3A}</a:tableStyleId>
               </a:tblPr>
               <a:tblGrid>
-                <a:gridCol w="1371600"/>
-                <a:gridCol w="4297680"/>
+                <a:gridCol w="1463040"/>
+                <a:gridCol w="4206240"/>
               </a:tblGrid>
-              <a:tr h="347472">
+              <a:tr h="320040">
                 <a:tc>
                   <a:txBody>
                     <a:bodyPr/>
                     <a:lstStyle/>
                     <a:p>
                       <a:r>
-                        <a:rPr sz="1100">
+                        <a:rPr sz="1050">
                           <a:latin typeface="Calibri"/>
                         </a:rPr>
-                        <a:t>Attribute</a:t>
+                        <a:t>Metadata Attribute</a:t>
                       </a:r>
                     </a:p>
                   </a:txBody>
@@ -6858,7 +8262,7 @@
                     <a:lstStyle/>
                     <a:p>
                       <a:r>
-                        <a:rPr sz="1100">
+                        <a:rPr sz="1050">
                           <a:latin typeface="Calibri"/>
                         </a:rPr>
                         <a:t>Detail</a:t>
@@ -6872,17 +8276,17 @@
                   </a:tcPr>
                 </a:tc>
               </a:tr>
-              <a:tr h="347472">
+              <a:tr h="320040">
                 <a:tc>
                   <a:txBody>
                     <a:bodyPr/>
                     <a:lstStyle/>
                     <a:p>
                       <a:r>
-                        <a:rPr sz="1100">
+                        <a:rPr sz="1050">
                           <a:latin typeface="Calibri"/>
                         </a:rPr>
-                        <a:t>Source</a:t>
+                        <a:t>Data Source</a:t>
                       </a:r>
                     </a:p>
                   </a:txBody>
@@ -6898,10 +8302,10 @@
                     <a:lstStyle/>
                     <a:p>
                       <a:r>
-                        <a:rPr sz="1100">
+                        <a:rPr sz="1050">
                           <a:latin typeface="Calibri"/>
                         </a:rPr>
-                        <a:t>Kaggle - Indian Weather Dataset (1996–2026)</a:t>
+                        <a:t>Kaggle - sandeepgupta09 / Indian Weather Dataset 1996-2026</a:t>
                       </a:r>
                     </a:p>
                   </a:txBody>
@@ -6912,17 +8316,17 @@
                   </a:tcPr>
                 </a:tc>
               </a:tr>
-              <a:tr h="347472">
+              <a:tr h="320040">
                 <a:tc>
                   <a:txBody>
                     <a:bodyPr/>
                     <a:lstStyle/>
                     <a:p>
                       <a:r>
-                        <a:rPr sz="1100">
+                        <a:rPr sz="1050">
                           <a:latin typeface="Calibri"/>
                         </a:rPr>
-                        <a:t>Coverage</a:t>
+                        <a:t>Access Link</a:t>
                       </a:r>
                     </a:p>
                   </a:txBody>
@@ -6938,10 +8342,10 @@
                     <a:lstStyle/>
                     <a:p>
                       <a:r>
-                        <a:rPr sz="1100">
+                        <a:rPr sz="1050">
                           <a:latin typeface="Calibri"/>
                         </a:rPr>
-                        <a:t>01 Jan 1996 → 18 Mar 2026</a:t>
+                        <a:t>kaggle.com/datasets/sandeepgupta09/indian-weather-dataset-1996-2026</a:t>
                       </a:r>
                     </a:p>
                   </a:txBody>
@@ -6952,17 +8356,17 @@
                   </a:tcPr>
                 </a:tc>
               </a:tr>
-              <a:tr h="347472">
+              <a:tr h="320040">
                 <a:tc>
                   <a:txBody>
                     <a:bodyPr/>
                     <a:lstStyle/>
                     <a:p>
                       <a:r>
-                        <a:rPr sz="1100">
+                        <a:rPr sz="1050">
                           <a:latin typeface="Calibri"/>
                         </a:rPr>
-                        <a:t>Time Index</a:t>
+                        <a:t>License</a:t>
                       </a:r>
                     </a:p>
                   </a:txBody>
@@ -6978,10 +8382,10 @@
                     <a:lstStyle/>
                     <a:p>
                       <a:r>
-                        <a:rPr sz="1100">
+                        <a:rPr sz="1050">
                           <a:latin typeface="Calibri"/>
                         </a:rPr>
-                        <a:t>'datetime' (Hourly)</a:t>
+                        <a:t>CC0: Public Domain (verified on Kaggle page)</a:t>
                       </a:r>
                     </a:p>
                   </a:txBody>
@@ -6992,17 +8396,17 @@
                   </a:tcPr>
                 </a:tc>
               </a:tr>
-              <a:tr h="347472">
+              <a:tr h="320040">
                 <a:tc>
                   <a:txBody>
                     <a:bodyPr/>
                     <a:lstStyle/>
                     <a:p>
                       <a:r>
-                        <a:rPr sz="1100">
+                        <a:rPr sz="1050">
                           <a:latin typeface="Calibri"/>
                         </a:rPr>
-                        <a:t>Volume</a:t>
+                        <a:t>Temporal Period</a:t>
                       </a:r>
                     </a:p>
                   </a:txBody>
@@ -7018,10 +8422,10 @@
                     <a:lstStyle/>
                     <a:p>
                       <a:r>
-                        <a:rPr sz="1100">
+                        <a:rPr sz="1050">
                           <a:latin typeface="Calibri"/>
                         </a:rPr>
-                        <a:t>264,840 raw → 11,035 daily points</a:t>
+                        <a:t>Over 30 years: 1 January 1996 to 18 March 2026</a:t>
                       </a:r>
                     </a:p>
                   </a:txBody>
@@ -7032,14 +8436,94 @@
                   </a:tcPr>
                 </a:tc>
               </a:tr>
-              <a:tr h="347472">
+              <a:tr h="320040">
                 <a:tc>
                   <a:txBody>
                     <a:bodyPr/>
                     <a:lstStyle/>
                     <a:p>
                       <a:r>
-                        <a:rPr sz="1100">
+                        <a:rPr sz="1050">
+                          <a:latin typeface="Calibri"/>
+                        </a:rPr>
+                        <a:t>Time Index &amp; Freq</a:t>
+                      </a:r>
+                    </a:p>
+                  </a:txBody>
+                  <a:tcPr anchor="ctr">
+                    <a:solidFill>
+                      <a:srgbClr val="FFFFFF"/>
+                    </a:solidFill>
+                  </a:tcPr>
+                </a:tc>
+                <a:tc>
+                  <a:txBody>
+                    <a:bodyPr/>
+                    <a:lstStyle/>
+                    <a:p>
+                      <a:r>
+                        <a:rPr sz="1050">
+                          <a:latin typeface="Calibri"/>
+                        </a:rPr>
+                        <a:t>'datetime' (Hourly, regular)</a:t>
+                      </a:r>
+                    </a:p>
+                  </a:txBody>
+                  <a:tcPr anchor="ctr">
+                    <a:solidFill>
+                      <a:srgbClr val="FFFFFF"/>
+                    </a:solidFill>
+                  </a:tcPr>
+                </a:tc>
+              </a:tr>
+              <a:tr h="320040">
+                <a:tc>
+                  <a:txBody>
+                    <a:bodyPr/>
+                    <a:lstStyle/>
+                    <a:p>
+                      <a:r>
+                        <a:rPr sz="1050">
+                          <a:latin typeface="Calibri"/>
+                        </a:rPr>
+                        <a:t>Data Volume</a:t>
+                      </a:r>
+                    </a:p>
+                  </a:txBody>
+                  <a:tcPr anchor="ctr">
+                    <a:solidFill>
+                      <a:srgbClr val="EEF3F9"/>
+                    </a:solidFill>
+                  </a:tcPr>
+                </a:tc>
+                <a:tc>
+                  <a:txBody>
+                    <a:bodyPr/>
+                    <a:lstStyle/>
+                    <a:p>
+                      <a:r>
+                        <a:rPr sz="1050">
+                          <a:latin typeface="Calibri"/>
+                        </a:rPr>
+                        <a:t>264,840 hourly rows → 11,035 daily points (≥500 required)</a:t>
+                      </a:r>
+                    </a:p>
+                  </a:txBody>
+                  <a:tcPr anchor="ctr">
+                    <a:solidFill>
+                      <a:srgbClr val="EEF3F9"/>
+                    </a:solidFill>
+                  </a:tcPr>
+                </a:tc>
+              </a:tr>
+              <a:tr h="320040">
+                <a:tc>
+                  <a:txBody>
+                    <a:bodyPr/>
+                    <a:lstStyle/>
+                    <a:p>
+                      <a:r>
+                        <a:rPr sz="1050">
                           <a:latin typeface="Calibri"/>
                         </a:rPr>
                         <a:t>Format</a:t>
@@ -7058,10 +8542,10 @@
                     <a:lstStyle/>
                     <a:p>
                       <a:r>
-                        <a:rPr sz="1100">
+                        <a:rPr sz="1050">
                           <a:latin typeface="Calibri"/>
                         </a:rPr>
-                        <a:t>CSV (Time-indexed)</a:t>
+                        <a:t>Standard Time-Indexed CSV</a:t>
                       </a:r>
                     </a:p>
                   </a:txBody>
@@ -7285,7 +8769,7 @@
                         <a:rPr sz="950">
                           <a:latin typeface="Calibri"/>
                         </a:rPr>
-                        <a:t>11.5</a:t>
+                        <a:t>11.3</a:t>
                       </a:r>
                     </a:p>
                   </a:txBody>
@@ -7323,7 +8807,7 @@
                         <a:rPr sz="950">
                           <a:latin typeface="Calibri"/>
                         </a:rPr>
-                        <a:t>82</a:t>
+                        <a:t>83</a:t>
                       </a:r>
                     </a:p>
                   </a:txBody>
@@ -7597,7 +9081,7 @@
                         <a:rPr sz="950">
                           <a:latin typeface="Calibri"/>
                         </a:rPr>
-                        <a:t>10.3</a:t>
+                        <a:t>9.8</a:t>
                       </a:r>
                     </a:p>
                   </a:txBody>
@@ -7635,7 +9119,7 @@
                         <a:rPr sz="950">
                           <a:latin typeface="Calibri"/>
                         </a:rPr>
-                        <a:t>89</a:t>
+                        <a:t>91</a:t>
                       </a:r>
                     </a:p>
                   </a:txBody>
@@ -7675,7 +9159,7 @@
                         <a:rPr sz="950">
                           <a:latin typeface="Calibri"/>
                         </a:rPr>
-                        <a:t>9.8</a:t>
+                        <a:t>9.4</a:t>
                       </a:r>
                     </a:p>
                   </a:txBody>
@@ -7713,7 +9197,7 @@
                         <a:rPr sz="950">
                           <a:latin typeface="Calibri"/>
                         </a:rPr>
-                        <a:t>91</a:t>
+                        <a:t>92</a:t>
                       </a:r>
                     </a:p>
                   </a:txBody>
@@ -7736,8 +9220,8 @@
         </p:nvSpPr>
         <p:spPr>
           <a:xfrm>
-            <a:off x="6400800" y="3931920"/>
-            <a:ext cx="5330952" cy="2286000"/>
+            <a:off x="6400800" y="4023360"/>
+            <a:ext cx="5330952" cy="2194560"/>
           </a:xfrm>
           <a:prstGeom prst="roundRect">
             <a:avLst/>
@@ -7781,7 +9265,7 @@
         </p:nvSpPr>
         <p:spPr>
           <a:xfrm>
-            <a:off x="6537960" y="4023359"/>
+            <a:off x="6537960" y="4114800"/>
             <a:ext cx="5056632" cy="320040"/>
           </a:xfrm>
           <a:prstGeom prst="rect">
@@ -7801,13 +9285,13 @@
               </a:spcAft>
             </a:pPr>
             <a:r>
-              <a:rPr sz="1350" b="1">
+              <a:rPr sz="1300" b="1">
                 <a:solidFill>
                   <a:srgbClr val="1F4E79"/>
                 </a:solidFill>
                 <a:latin typeface="Calibri"/>
               </a:rPr>
-              <a:t>Dataset Checklist</a:t>
+              <a:t>Phase-1 Dataset Checklist</a:t>
             </a:r>
           </a:p>
         </p:txBody>
@@ -7820,8 +9304,8 @@
         </p:nvSpPr>
         <p:spPr>
           <a:xfrm>
-            <a:off x="6537960" y="4389120"/>
-            <a:ext cx="5056632" cy="1737360"/>
+            <a:off x="6537960" y="4480560"/>
+            <a:ext cx="5056632" cy="1645919"/>
           </a:xfrm>
           <a:prstGeom prst="rect">
             <a:avLst/>
@@ -7840,13 +9324,13 @@
               </a:spcAft>
             </a:pPr>
             <a:r>
-              <a:rPr sz="1150" b="0">
+              <a:rPr sz="1100" b="0">
                 <a:solidFill>
                   <a:srgbClr val="1B2A3C"/>
                 </a:solidFill>
                 <a:latin typeface="Calibri"/>
               </a:rPr>
-              <a:t>•  ✓ Proper time column present and regular</a:t>
+              <a:t>•  ✓ Verified continuous timestamp column with regular hourly intervals</a:t>
             </a:r>
           </a:p>
           <a:p>
@@ -7856,13 +9340,13 @@
               </a:spcAft>
             </a:pPr>
             <a:r>
-              <a:rPr sz="1150" b="0">
+              <a:rPr sz="1100" b="0">
                 <a:solidFill>
                   <a:srgbClr val="1B2A3C"/>
                 </a:solidFill>
                 <a:latin typeface="Calibri"/>
               </a:rPr>
-              <a:t>•  ✓ 11,035 daily observations (≥500 required)</a:t>
+              <a:t>•  ✓ Volume: 11,035 daily observations (Exceeds ≥500 requirement)</a:t>
             </a:r>
           </a:p>
           <a:p>
@@ -7872,13 +9356,13 @@
               </a:spcAft>
             </a:pPr>
             <a:r>
-              <a:rPr sz="1150" b="0">
+              <a:rPr sz="1100" b="0">
                 <a:solidFill>
                   <a:srgbClr val="1B2A3C"/>
                 </a:solidFill>
                 <a:latin typeface="Calibri"/>
               </a:rPr>
-              <a:t>•  ✓ Source and variable dictionary documented</a:t>
+              <a:t>•  ✓ Source repository and CC0 license verified on Kaggle page</a:t>
             </a:r>
           </a:p>
           <a:p>
@@ -7888,13 +9372,13 @@
               </a:spcAft>
             </a:pPr>
             <a:r>
-              <a:rPr sz="1150" b="0">
+              <a:rPr sz="1100" b="0">
                 <a:solidFill>
                   <a:srgbClr val="1B2A3C"/>
                 </a:solidFill>
                 <a:latin typeface="Calibri"/>
               </a:rPr>
-              <a:t>•  ✓ Numeric types validated</a:t>
+              <a:t>•  ✓ Data dictionary and units documented (°C, mm, %)</a:t>
             </a:r>
           </a:p>
         </p:txBody>
@@ -8123,7 +9607,7 @@
                 </a:solidFill>
                 <a:latin typeface="Calibri"/>
               </a:rPr>
-              <a:t>5 / 11</a:t>
+              <a:t>5 / 12</a:t>
             </a:r>
           </a:p>
         </p:txBody>
@@ -8137,7 +9621,7 @@
         <p:spPr>
           <a:xfrm>
             <a:off x="457200" y="1280160"/>
-            <a:ext cx="2103120" cy="1143000"/>
+            <a:ext cx="1783080" cy="1143000"/>
           </a:xfrm>
           <a:prstGeom prst="roundRect">
             <a:avLst/>
@@ -8182,7 +9666,7 @@
         <p:spPr>
           <a:xfrm>
             <a:off x="457200" y="1353312"/>
-            <a:ext cx="2103120" cy="594360"/>
+            <a:ext cx="1783080" cy="594360"/>
           </a:xfrm>
           <a:prstGeom prst="rect">
             <a:avLst/>
@@ -8221,7 +9705,7 @@
         <p:spPr>
           <a:xfrm>
             <a:off x="457200" y="1908810"/>
-            <a:ext cx="2103120" cy="457200"/>
+            <a:ext cx="1783080" cy="457200"/>
           </a:xfrm>
           <a:prstGeom prst="rect">
             <a:avLst/>
@@ -8246,7 +9730,7 @@
                 </a:solidFill>
                 <a:latin typeface="Calibri"/>
               </a:rPr>
-              <a:t>Raw Rows</a:t>
+              <a:t>Hourly Observations</a:t>
             </a:r>
           </a:p>
         </p:txBody>
@@ -8259,8 +9743,8 @@
         </p:nvSpPr>
         <p:spPr>
           <a:xfrm>
-            <a:off x="2743200" y="1280160"/>
-            <a:ext cx="2103120" cy="1143000"/>
+            <a:off x="2350008" y="1280160"/>
+            <a:ext cx="1783080" cy="1143000"/>
           </a:xfrm>
           <a:prstGeom prst="roundRect">
             <a:avLst/>
@@ -8304,8 +9788,8 @@
         </p:nvSpPr>
         <p:spPr>
           <a:xfrm>
-            <a:off x="2743200" y="1353312"/>
-            <a:ext cx="2103120" cy="594360"/>
+            <a:off x="2350008" y="1353312"/>
+            <a:ext cx="1783080" cy="594360"/>
           </a:xfrm>
           <a:prstGeom prst="rect">
             <a:avLst/>
@@ -8343,8 +9827,8 @@
         </p:nvSpPr>
         <p:spPr>
           <a:xfrm>
-            <a:off x="2743200" y="1908810"/>
-            <a:ext cx="2103120" cy="457200"/>
+            <a:off x="2350008" y="1908810"/>
+            <a:ext cx="1783080" cy="457200"/>
           </a:xfrm>
           <a:prstGeom prst="rect">
             <a:avLst/>
@@ -8369,7 +9853,7 @@
                 </a:solidFill>
                 <a:latin typeface="Calibri"/>
               </a:rPr>
-              <a:t>Duplicates</a:t>
+              <a:t>Duplicate Timestamps</a:t>
             </a:r>
           </a:p>
         </p:txBody>
@@ -8382,8 +9866,8 @@
         </p:nvSpPr>
         <p:spPr>
           <a:xfrm>
-            <a:off x="5029200" y="1280160"/>
-            <a:ext cx="2103120" cy="1143000"/>
+            <a:off x="4242816" y="1280160"/>
+            <a:ext cx="1783080" cy="1143000"/>
           </a:xfrm>
           <a:prstGeom prst="roundRect">
             <a:avLst/>
@@ -8427,8 +9911,8 @@
         </p:nvSpPr>
         <p:spPr>
           <a:xfrm>
-            <a:off x="5029200" y="1353312"/>
-            <a:ext cx="2103120" cy="594360"/>
+            <a:off x="4242816" y="1353312"/>
+            <a:ext cx="1783080" cy="594360"/>
           </a:xfrm>
           <a:prstGeom prst="rect">
             <a:avLst/>
@@ -8466,8 +9950,8 @@
         </p:nvSpPr>
         <p:spPr>
           <a:xfrm>
-            <a:off x="5029200" y="1908810"/>
-            <a:ext cx="2103120" cy="457200"/>
+            <a:off x="4242816" y="1908810"/>
+            <a:ext cx="1783080" cy="457200"/>
           </a:xfrm>
           <a:prstGeom prst="rect">
             <a:avLst/>
@@ -8492,7 +9976,7 @@
                 </a:solidFill>
                 <a:latin typeface="Calibri"/>
               </a:rPr>
-              <a:t>Temp Missing</a:t>
+              <a:t>Timestamp Gaps</a:t>
             </a:r>
           </a:p>
         </p:txBody>
@@ -8505,8 +9989,8 @@
         </p:nvSpPr>
         <p:spPr>
           <a:xfrm>
-            <a:off x="7315200" y="1280160"/>
-            <a:ext cx="2103120" cy="1143000"/>
+            <a:off x="6135623" y="1280160"/>
+            <a:ext cx="1783080" cy="1143000"/>
           </a:xfrm>
           <a:prstGeom prst="roundRect">
             <a:avLst/>
@@ -8550,8 +10034,8 @@
         </p:nvSpPr>
         <p:spPr>
           <a:xfrm>
-            <a:off x="7315200" y="1353312"/>
-            <a:ext cx="2103120" cy="594360"/>
+            <a:off x="6135623" y="1353312"/>
+            <a:ext cx="1783080" cy="594360"/>
           </a:xfrm>
           <a:prstGeom prst="rect">
             <a:avLst/>
@@ -8576,7 +10060,7 @@
                 </a:solidFill>
                 <a:latin typeface="Calibri"/>
               </a:rPr>
-              <a:t>11,035</a:t>
+              <a:t>0.00%</a:t>
             </a:r>
           </a:p>
         </p:txBody>
@@ -8589,8 +10073,8 @@
         </p:nvSpPr>
         <p:spPr>
           <a:xfrm>
-            <a:off x="7315200" y="1908810"/>
-            <a:ext cx="2103120" cy="457200"/>
+            <a:off x="6135623" y="1908810"/>
+            <a:ext cx="1783080" cy="457200"/>
           </a:xfrm>
           <a:prstGeom prst="rect">
             <a:avLst/>
@@ -8615,7 +10099,7 @@
                 </a:solidFill>
                 <a:latin typeface="Calibri"/>
               </a:rPr>
-              <a:t>Daily Points</a:t>
+              <a:t>Temp Missing %</a:t>
             </a:r>
           </a:p>
         </p:txBody>
@@ -8628,8 +10112,8 @@
         </p:nvSpPr>
         <p:spPr>
           <a:xfrm>
-            <a:off x="9601200" y="1280160"/>
-            <a:ext cx="2103120" cy="1143000"/>
+            <a:off x="8028431" y="1280160"/>
+            <a:ext cx="1783080" cy="1143000"/>
           </a:xfrm>
           <a:prstGeom prst="roundRect">
             <a:avLst/>
@@ -8673,8 +10157,8 @@
         </p:nvSpPr>
         <p:spPr>
           <a:xfrm>
-            <a:off x="9601200" y="1353312"/>
-            <a:ext cx="2103120" cy="594360"/>
+            <a:off x="8028431" y="1353312"/>
+            <a:ext cx="1783080" cy="594360"/>
           </a:xfrm>
           <a:prstGeom prst="rect">
             <a:avLst/>
@@ -8699,7 +10183,7 @@
                 </a:solidFill>
                 <a:latin typeface="Calibri"/>
               </a:rPr>
-              <a:t>High</a:t>
+              <a:t>11,035</a:t>
             </a:r>
           </a:p>
         </p:txBody>
@@ -8712,8 +10196,8 @@
         </p:nvSpPr>
         <p:spPr>
           <a:xfrm>
-            <a:off x="9601200" y="1908810"/>
-            <a:ext cx="2103120" cy="457200"/>
+            <a:off x="8028431" y="1908810"/>
+            <a:ext cx="1783080" cy="457200"/>
           </a:xfrm>
           <a:prstGeom prst="rect">
             <a:avLst/>
@@ -8738,14 +10222,137 @@
                 </a:solidFill>
                 <a:latin typeface="Calibri"/>
               </a:rPr>
-              <a:t>Continuity</a:t>
+              <a:t>Daily Points</a:t>
+            </a:r>
+          </a:p>
+        </p:txBody>
+      </p:sp>
+      <p:sp>
+        <p:nvSpPr>
+          <p:cNvPr id="22" name="Rounded Rectangle 21"/>
+          <p:cNvSpPr/>
+          <p:nvPr/>
+        </p:nvSpPr>
+        <p:spPr>
+          <a:xfrm>
+            <a:off x="9921240" y="1280160"/>
+            <a:ext cx="1783080" cy="1143000"/>
+          </a:xfrm>
+          <a:prstGeom prst="roundRect">
+            <a:avLst/>
+          </a:prstGeom>
+          <a:solidFill>
+            <a:srgbClr val="FFFFFF"/>
+          </a:solidFill>
+          <a:ln>
+            <a:solidFill>
+              <a:srgbClr val="D5DEE9"/>
+            </a:solidFill>
+          </a:ln>
+        </p:spPr>
+        <p:style>
+          <a:lnRef idx="1">
+            <a:schemeClr val="accent1"/>
+          </a:lnRef>
+          <a:fillRef idx="3">
+            <a:schemeClr val="accent1"/>
+          </a:fillRef>
+          <a:effectRef idx="2">
+            <a:schemeClr val="accent1"/>
+          </a:effectRef>
+          <a:fontRef idx="minor">
+            <a:schemeClr val="lt1"/>
+          </a:fontRef>
+        </p:style>
+        <p:txBody>
+          <a:bodyPr rtlCol="0" anchor="ctr"/>
+          <a:lstStyle/>
+          <a:p>
+            <a:pPr algn="ctr"/>
+          </a:p>
+        </p:txBody>
+      </p:sp>
+      <p:sp>
+        <p:nvSpPr>
+          <p:cNvPr id="23" name="TextBox 22"/>
+          <p:cNvSpPr txBox="1"/>
+          <p:nvPr/>
+        </p:nvSpPr>
+        <p:spPr>
+          <a:xfrm>
+            <a:off x="9921240" y="1353312"/>
+            <a:ext cx="1783080" cy="594360"/>
+          </a:xfrm>
+          <a:prstGeom prst="rect">
+            <a:avLst/>
+          </a:prstGeom>
+          <a:noFill/>
+        </p:spPr>
+        <p:txBody>
+          <a:bodyPr wrap="square" anchor="ctr">
+            <a:spAutoFit/>
+          </a:bodyPr>
+          <a:lstStyle/>
+          <a:p>
+            <a:pPr algn="ctr">
+              <a:spcAft>
+                <a:spcPts val="400"/>
+              </a:spcAft>
+            </a:pPr>
+            <a:r>
+              <a:rPr sz="2200" b="1">
+                <a:solidFill>
+                  <a:srgbClr val="F28C28"/>
+                </a:solidFill>
+                <a:latin typeface="Calibri"/>
+              </a:rPr>
+              <a:t>100%</a:t>
+            </a:r>
+          </a:p>
+        </p:txBody>
+      </p:sp>
+      <p:sp>
+        <p:nvSpPr>
+          <p:cNvPr id="24" name="TextBox 23"/>
+          <p:cNvSpPr txBox="1"/>
+          <p:nvPr/>
+        </p:nvSpPr>
+        <p:spPr>
+          <a:xfrm>
+            <a:off x="9921240" y="1908810"/>
+            <a:ext cx="1783080" cy="457200"/>
+          </a:xfrm>
+          <a:prstGeom prst="rect">
+            <a:avLst/>
+          </a:prstGeom>
+          <a:noFill/>
+        </p:spPr>
+        <p:txBody>
+          <a:bodyPr wrap="square" anchor="t">
+            <a:spAutoFit/>
+          </a:bodyPr>
+          <a:lstStyle/>
+          <a:p>
+            <a:pPr algn="ctr">
+              <a:spcAft>
+                <a:spcPts val="400"/>
+              </a:spcAft>
+            </a:pPr>
+            <a:r>
+              <a:rPr sz="1000" b="0">
+                <a:solidFill>
+                  <a:srgbClr val="6B7785"/>
+                </a:solidFill>
+                <a:latin typeface="Calibri"/>
+              </a:rPr>
+              <a:t>Time Continuity</a:t>
             </a:r>
           </a:p>
         </p:txBody>
       </p:sp>
       <p:pic>
         <p:nvPicPr>
-          <p:cNvPr id="22" name="Picture 21" descr="02_missing.png"/>
+          <p:cNvPr id="25" name="Picture 24" descr="02_missing_audit.png"/>
           <p:cNvPicPr>
             <a:picLocks noChangeAspect="1"/>
           </p:cNvPicPr>
@@ -8759,8 +10366,8 @@
         </p:blipFill>
         <p:spPr>
           <a:xfrm>
-            <a:off x="1556119" y="2606039"/>
-            <a:ext cx="9076712" cy="3154680"/>
+            <a:off x="1456892" y="2606040"/>
+            <a:ext cx="9275167" cy="3154680"/>
           </a:xfrm>
           <a:prstGeom prst="rect">
             <a:avLst/>
@@ -8769,7 +10376,7 @@
       </p:pic>
       <p:sp>
         <p:nvSpPr>
-          <p:cNvPr id="23" name="Rounded Rectangle 22"/>
+          <p:cNvPr id="26" name="Rounded Rectangle 25"/>
           <p:cNvSpPr/>
           <p:nvPr/>
         </p:nvSpPr>
@@ -8812,7 +10419,7 @@
       </p:sp>
       <p:sp>
         <p:nvSpPr>
-          <p:cNvPr id="24" name="TextBox 23"/>
+          <p:cNvPr id="27" name="TextBox 26"/>
           <p:cNvSpPr txBox="1"/>
           <p:nvPr/>
         </p:nvSpPr>
@@ -8844,7 +10451,7 @@
                 </a:solidFill>
                 <a:latin typeface="Calibri"/>
               </a:rPr>
-              <a:t>&gt;99.7% data completeness across 30 years. Short gaps will be interpolated in Phase 2.</a:t>
+              <a:t>Data Quality Finding: Exactly 264,840 hourly observations across 11,035 days with 0 duplicate timestamps and complete temporal continuity.</a:t>
             </a:r>
           </a:p>
         </p:txBody>
@@ -9073,7 +10680,7 @@
                 </a:solidFill>
                 <a:latin typeface="Calibri"/>
               </a:rPr>
-              <a:t>6 / 11</a:t>
+              <a:t>6 / 12</a:t>
             </a:r>
           </a:p>
         </p:txBody>
@@ -9094,8 +10701,8 @@
         </p:blipFill>
         <p:spPr>
           <a:xfrm>
-            <a:off x="365760" y="1566052"/>
-            <a:ext cx="7498079" cy="3451575"/>
+            <a:off x="365760" y="1559841"/>
+            <a:ext cx="7498079" cy="3463997"/>
           </a:xfrm>
           <a:prstGeom prst="rect">
             <a:avLst/>
@@ -9136,7 +10743,7 @@
                 </a:solidFill>
                 <a:latin typeface="Calibri"/>
               </a:rPr>
-              <a:t>Top 5 Hottest Days (Max Temp)</a:t>
+              <a:t>Top 5 Hottest Days (Daily Max)</a:t>
             </a:r>
           </a:p>
         </p:txBody>
@@ -9212,7 +10819,7 @@
                         <a:rPr sz="1000">
                           <a:latin typeface="Calibri"/>
                         </a:rPr>
-                        <a:t>Value</a:t>
+                        <a:t>Recorded Value</a:t>
                       </a:r>
                     </a:p>
                   </a:txBody>
@@ -9271,7 +10878,7 @@
                         <a:rPr sz="1000">
                           <a:latin typeface="Calibri"/>
                         </a:rPr>
-                        <a:t>46.8 °C</a:t>
+                        <a:t>46.9 °C</a:t>
                       </a:r>
                     </a:p>
                   </a:txBody>
@@ -9311,7 +10918,7 @@
                         <a:rPr sz="1000">
                           <a:latin typeface="Calibri"/>
                         </a:rPr>
-                        <a:t>28 May 1998</a:t>
+                        <a:t>30 May 2024</a:t>
                       </a:r>
                     </a:p>
                   </a:txBody>
@@ -9370,7 +10977,7 @@
                         <a:rPr sz="1000">
                           <a:latin typeface="Calibri"/>
                         </a:rPr>
-                        <a:t>29 May 2024</a:t>
+                        <a:t>28 May 1998</a:t>
                       </a:r>
                     </a:p>
                   </a:txBody>
@@ -9389,7 +10996,7 @@
                         <a:rPr sz="1000">
                           <a:latin typeface="Calibri"/>
                         </a:rPr>
-                        <a:t>46.1 °C</a:t>
+                        <a:t>46.2 °C</a:t>
                       </a:r>
                     </a:p>
                   </a:txBody>
@@ -9429,7 +11036,7 @@
                         <a:rPr sz="1000">
                           <a:latin typeface="Calibri"/>
                         </a:rPr>
-                        <a:t>27 May 1998</a:t>
+                        <a:t>29 May 2024</a:t>
                       </a:r>
                     </a:p>
                   </a:txBody>
@@ -9448,7 +11055,7 @@
                         <a:rPr sz="1000">
                           <a:latin typeface="Calibri"/>
                         </a:rPr>
-                        <a:t>46.0 °C</a:t>
+                        <a:t>46.1 °C</a:t>
                       </a:r>
                     </a:p>
                   </a:txBody>
@@ -9488,7 +11095,7 @@
                         <a:rPr sz="1000">
                           <a:latin typeface="Calibri"/>
                         </a:rPr>
-                        <a:t>18 May 2002</a:t>
+                        <a:t>24 May 1998</a:t>
                       </a:r>
                     </a:p>
                   </a:txBody>
@@ -9507,7 +11114,7 @@
                         <a:rPr sz="1000">
                           <a:latin typeface="Calibri"/>
                         </a:rPr>
-                        <a:t>45.9 °C</a:t>
+                        <a:t>46.0 °C</a:t>
                       </a:r>
                     </a:p>
                   </a:txBody>
@@ -9556,7 +11163,7 @@
                 </a:solidFill>
                 <a:latin typeface="Calibri"/>
               </a:rPr>
-              <a:t>Top 5 Coldest Days (Min Temp)</a:t>
+              <a:t>Top 5 Coldest Days (Daily Min)</a:t>
             </a:r>
           </a:p>
         </p:txBody>
@@ -9632,7 +11239,7 @@
                         <a:rPr sz="1000">
                           <a:latin typeface="Calibri"/>
                         </a:rPr>
-                        <a:t>Value</a:t>
+                        <a:t>Recorded Value</a:t>
                       </a:r>
                     </a:p>
                   </a:txBody>
@@ -9691,7 +11298,7 @@
                         <a:rPr sz="1000">
                           <a:latin typeface="Calibri"/>
                         </a:rPr>
-                        <a:t>2.0 °C</a:t>
+                        <a:t>1.3 °C</a:t>
                       </a:r>
                     </a:p>
                   </a:txBody>
@@ -9750,7 +11357,7 @@
                         <a:rPr sz="1000">
                           <a:latin typeface="Calibri"/>
                         </a:rPr>
-                        <a:t>2.2 °C</a:t>
+                        <a:t>1.9 °C</a:t>
                       </a:r>
                     </a:p>
                   </a:txBody>
@@ -9790,7 +11397,7 @@
                         <a:rPr sz="1000">
                           <a:latin typeface="Calibri"/>
                         </a:rPr>
-                        <a:t>18 Jan 1998</a:t>
+                        <a:t>01 Jan 2020</a:t>
                       </a:r>
                     </a:p>
                   </a:txBody>
@@ -9809,7 +11416,7 @@
                         <a:rPr sz="1000">
                           <a:latin typeface="Calibri"/>
                         </a:rPr>
-                        <a:t>2.3 °C</a:t>
+                        <a:t>1.9 °C</a:t>
                       </a:r>
                     </a:p>
                   </a:txBody>
@@ -9849,7 +11456,7 @@
                         <a:rPr sz="1000">
                           <a:latin typeface="Calibri"/>
                         </a:rPr>
-                        <a:t>16 Jan 2023</a:t>
+                        <a:t>28 Dec 2019</a:t>
                       </a:r>
                     </a:p>
                   </a:txBody>
@@ -9868,7 +11475,7 @@
                         <a:rPr sz="1000">
                           <a:latin typeface="Calibri"/>
                         </a:rPr>
-                        <a:t>2.4 °C</a:t>
+                        <a:t>2.0 °C</a:t>
                       </a:r>
                     </a:p>
                   </a:txBody>
@@ -9908,7 +11515,7 @@
                         <a:rPr sz="1000">
                           <a:latin typeface="Calibri"/>
                         </a:rPr>
-                        <a:t>18 Jan 2023</a:t>
+                        <a:t>30 Dec 2019</a:t>
                       </a:r>
                     </a:p>
                   </a:txBody>
@@ -9927,7 +11534,7 @@
                         <a:rPr sz="1000">
                           <a:latin typeface="Calibri"/>
                         </a:rPr>
-                        <a:t>2.4 °C</a:t>
+                        <a:t>2.2 °C</a:t>
                       </a:r>
                     </a:p>
                   </a:txBody>
@@ -10019,7 +11626,7 @@
                 </a:solidFill>
                 <a:latin typeface="Calibri"/>
               </a:rPr>
-              <a:t>30-Day moving average is an exploratory smoothing aid only; no prediction is performed.</a:t>
+              <a:t>30-Day moving average is an exploratory visual smoothing aid only; no predictive modeling is executed in Milestone 1.</a:t>
             </a:r>
           </a:p>
         </p:txBody>
@@ -10248,14 +11855,14 @@
                 </a:solidFill>
                 <a:latin typeface="Calibri"/>
               </a:rPr>
-              <a:t>7 / 11</a:t>
+              <a:t>7 / 12</a:t>
             </a:r>
           </a:p>
         </p:txBody>
       </p:sp>
       <p:pic>
         <p:nvPicPr>
-          <p:cNvPr id="7" name="Picture 6" descr="03_fingerprint.png"/>
+          <p:cNvPr id="7" name="Picture 6" descr="03_climate_fingerprint.png"/>
           <p:cNvPicPr>
             <a:picLocks noChangeAspect="1"/>
           </p:cNvPicPr>
@@ -10279,7 +11886,7 @@
       </p:pic>
       <p:pic>
         <p:nvPicPr>
-          <p:cNvPr id="8" name="Picture 7" descr="04_heatmap.png"/>
+          <p:cNvPr id="8" name="Picture 7" descr="04_thermal_heatmap.png"/>
           <p:cNvPicPr>
             <a:picLocks noChangeAspect="1"/>
           </p:cNvPicPr>
@@ -10293,8 +11900,8 @@
         </p:blipFill>
         <p:spPr>
           <a:xfrm>
-            <a:off x="6130845" y="1188720"/>
-            <a:ext cx="5660549" cy="4434840"/>
+            <a:off x="6213564" y="1188720"/>
+            <a:ext cx="5495111" cy="4434840"/>
           </a:xfrm>
           <a:prstGeom prst="rect">
             <a:avLst/>
@@ -10378,7 +11985,7 @@
                 </a:solidFill>
                 <a:latin typeface="Calibri"/>
               </a:rPr>
-              <a:t>Hottest Month: Jun (32.8°C) | Coldest Month: Jan (13.1°C) | Annual Swing: ~19.8°C</a:t>
+              <a:t>Hottest Month: Jun (32.8°C) | Coldest Month: Jan (12.9°C) | Annual Thermal Swing: ~19.9°C</a:t>
             </a:r>
           </a:p>
         </p:txBody>
@@ -10529,7 +12136,7 @@
                 </a:solidFill>
                 <a:latin typeface="Calibri"/>
               </a:rPr>
-              <a:t>Time-Series Decomposition (STL)</a:t>
+              <a:t>Time-Series Decomposition (LOESS-Based STL)</a:t>
             </a:r>
           </a:p>
         </p:txBody>
@@ -10607,14 +12214,14 @@
                 </a:solidFill>
                 <a:latin typeface="Calibri"/>
               </a:rPr>
-              <a:t>8 / 11</a:t>
+              <a:t>8 / 12</a:t>
             </a:r>
           </a:p>
         </p:txBody>
       </p:sp>
       <p:pic>
         <p:nvPicPr>
-          <p:cNvPr id="7" name="Picture 6" descr="05_decomp.png"/>
+          <p:cNvPr id="7" name="Picture 6" descr="05_stl_decomposition.png"/>
           <p:cNvPicPr>
             <a:picLocks noChangeAspect="1"/>
           </p:cNvPicPr>
@@ -10628,8 +12235,8 @@
         </p:blipFill>
         <p:spPr>
           <a:xfrm>
-            <a:off x="365760" y="1437375"/>
-            <a:ext cx="7498079" cy="4669049"/>
+            <a:off x="365760" y="1435941"/>
+            <a:ext cx="7498079" cy="4671916"/>
           </a:xfrm>
           <a:prstGeom prst="rect">
             <a:avLst/>
@@ -10715,7 +12322,7 @@
                 </a:solidFill>
                 <a:latin typeface="Calibri"/>
               </a:rPr>
-              <a:t>0.93</a:t>
+              <a:t>0.94</a:t>
             </a:r>
           </a:p>
         </p:txBody>
@@ -10754,7 +12361,7 @@
                 </a:solidFill>
                 <a:latin typeface="Calibri"/>
               </a:rPr>
-              <a:t>Seasonal Strength (Fs)</a:t>
+              <a:t>Seasonal Strength (Fs, 0–1)</a:t>
             </a:r>
           </a:p>
         </p:txBody>
@@ -10834,7 +12441,7 @@
             <a:r>
               <a:rPr sz="2200" b="1">
                 <a:solidFill>
-                  <a:srgbClr val="F28C28"/>
+                  <a:srgbClr val="1F4E79"/>
                 </a:solidFill>
                 <a:latin typeface="Calibri"/>
               </a:rPr>
@@ -10877,21 +12484,105 @@
                 </a:solidFill>
                 <a:latin typeface="Calibri"/>
               </a:rPr>
-              <a:t>Trend Strength (Ft)</a:t>
-            </a:r>
-          </a:p>
-        </p:txBody>
-      </p:sp>
-      <p:sp>
-        <p:nvSpPr>
-          <p:cNvPr id="14" name="TextBox 13"/>
+              <a:t>Trend Strength (Ft, 0–1)</a:t>
+            </a:r>
+          </a:p>
+        </p:txBody>
+      </p:sp>
+      <p:sp>
+        <p:nvSpPr>
+          <p:cNvPr id="14" name="Rounded Rectangle 13"/>
+          <p:cNvSpPr/>
+          <p:nvPr/>
+        </p:nvSpPr>
+        <p:spPr>
+          <a:xfrm>
+            <a:off x="8138160" y="3931920"/>
+            <a:ext cx="3566160" cy="1188720"/>
+          </a:xfrm>
+          <a:prstGeom prst="roundRect">
+            <a:avLst/>
+          </a:prstGeom>
+          <a:solidFill>
+            <a:srgbClr val="FFFFFF"/>
+          </a:solidFill>
+          <a:ln>
+            <a:solidFill>
+              <a:srgbClr val="D5DEE9"/>
+            </a:solidFill>
+          </a:ln>
+        </p:spPr>
+        <p:style>
+          <a:lnRef idx="1">
+            <a:schemeClr val="accent1"/>
+          </a:lnRef>
+          <a:fillRef idx="3">
+            <a:schemeClr val="accent1"/>
+          </a:fillRef>
+          <a:effectRef idx="2">
+            <a:schemeClr val="accent1"/>
+          </a:effectRef>
+          <a:fontRef idx="minor">
+            <a:schemeClr val="lt1"/>
+          </a:fontRef>
+        </p:style>
+        <p:txBody>
+          <a:bodyPr rtlCol="0" anchor="ctr"/>
+          <a:lstStyle/>
+          <a:p>
+            <a:pPr algn="ctr"/>
+          </a:p>
+        </p:txBody>
+      </p:sp>
+      <p:sp>
+        <p:nvSpPr>
+          <p:cNvPr id="15" name="TextBox 14"/>
           <p:cNvSpPr txBox="1"/>
           <p:nvPr/>
         </p:nvSpPr>
         <p:spPr>
           <a:xfrm>
-            <a:off x="8138160" y="4023360"/>
-            <a:ext cx="3566160" cy="1828800"/>
+            <a:off x="8138160" y="4005072"/>
+            <a:ext cx="3566160" cy="618134"/>
+          </a:xfrm>
+          <a:prstGeom prst="rect">
+            <a:avLst/>
+          </a:prstGeom>
+          <a:noFill/>
+        </p:spPr>
+        <p:txBody>
+          <a:bodyPr wrap="square" anchor="ctr">
+            <a:spAutoFit/>
+          </a:bodyPr>
+          <a:lstStyle/>
+          <a:p>
+            <a:pPr algn="ctr">
+              <a:spcAft>
+                <a:spcPts val="400"/>
+              </a:spcAft>
+            </a:pPr>
+            <a:r>
+              <a:rPr sz="2200" b="1">
+                <a:solidFill>
+                  <a:srgbClr val="6B7785"/>
+                </a:solidFill>
+                <a:latin typeface="Calibri"/>
+              </a:rPr>
+              <a:t>1.79 °C</a:t>
+            </a:r>
+          </a:p>
+        </p:txBody>
+      </p:sp>
+      <p:sp>
+        <p:nvSpPr>
+          <p:cNvPr id="16" name="TextBox 15"/>
+          <p:cNvSpPr txBox="1"/>
+          <p:nvPr/>
+        </p:nvSpPr>
+        <p:spPr>
+          <a:xfrm>
+            <a:off x="8138160" y="4585716"/>
+            <a:ext cx="3566160" cy="475488"/>
           </a:xfrm>
           <a:prstGeom prst="rect">
             <a:avLst/>
@@ -10904,6 +12595,45 @@
           </a:bodyPr>
           <a:lstStyle/>
           <a:p>
+            <a:pPr algn="ctr">
+              <a:spcAft>
+                <a:spcPts val="400"/>
+              </a:spcAft>
+            </a:pPr>
+            <a:r>
+              <a:rPr sz="1000" b="0">
+                <a:solidFill>
+                  <a:srgbClr val="6B7785"/>
+                </a:solidFill>
+                <a:latin typeface="Calibri"/>
+              </a:rPr>
+              <a:t>Residual Std. Deviation</a:t>
+            </a:r>
+          </a:p>
+        </p:txBody>
+      </p:sp>
+      <p:sp>
+        <p:nvSpPr>
+          <p:cNvPr id="17" name="TextBox 16"/>
+          <p:cNvSpPr txBox="1"/>
+          <p:nvPr/>
+        </p:nvSpPr>
+        <p:spPr>
+          <a:xfrm>
+            <a:off x="8138160" y="5257800"/>
+            <a:ext cx="3566160" cy="1005840"/>
+          </a:xfrm>
+          <a:prstGeom prst="rect">
+            <a:avLst/>
+          </a:prstGeom>
+          <a:noFill/>
+        </p:spPr>
+        <p:txBody>
+          <a:bodyPr wrap="square" anchor="t">
+            <a:spAutoFit/>
+          </a:bodyPr>
+          <a:lstStyle/>
+          <a:p>
             <a:pPr algn="l">
               <a:spcAft>
                 <a:spcPts val="400"/>
@@ -10916,7 +12646,7 @@
                 </a:solidFill>
                 <a:latin typeface="Calibri"/>
               </a:rPr>
-              <a:t>Observed = Trend + Seasonal + Residual. High seasonal strength (Fs &gt; 0.85) indicates that seasonal terms (e.g., SARIMA, Holt-Winters) are required for later modeling.</a:t>
+              <a:t>Decomposition Formula: Observed = Trend + Seasonal + Residual. The strong annual seasonal pattern motivates investigation of seasonal forecasting models in Phase 2.</a:t>
             </a:r>
           </a:p>
         </p:txBody>
@@ -11067,7 +12797,7 @@
                 </a:solidFill>
                 <a:latin typeface="Calibri"/>
               </a:rPr>
-              <a:t>Seasonal Distributions &amp; Temperature–Rain Relationship</a:t>
+              <a:t>Seasonal Distributions &amp; Temperature–Precipitation Associations</a:t>
             </a:r>
           </a:p>
         </p:txBody>
@@ -11145,14 +12875,14 @@
                 </a:solidFill>
                 <a:latin typeface="Calibri"/>
               </a:rPr>
-              <a:t>9 / 11</a:t>
+              <a:t>9 / 12</a:t>
             </a:r>
           </a:p>
         </p:txBody>
       </p:sp>
       <p:pic>
         <p:nvPicPr>
-          <p:cNvPr id="7" name="Picture 6" descr="06_box.png"/>
+          <p:cNvPr id="7" name="Picture 6" descr="06_seasonal_boxplot.png"/>
           <p:cNvPicPr>
             <a:picLocks noChangeAspect="1"/>
           </p:cNvPicPr>
@@ -11176,7 +12906,7 @@
       </p:pic>
       <p:pic>
         <p:nvPicPr>
-          <p:cNvPr id="8" name="Picture 7" descr="07_temp_rain.png"/>
+          <p:cNvPr id="8" name="Picture 7" descr="07_temp_vs_rain.png"/>
           <p:cNvPicPr>
             <a:picLocks noChangeAspect="1"/>
           </p:cNvPicPr>
@@ -11275,7 +13005,7 @@
                 </a:solidFill>
                 <a:latin typeface="Calibri"/>
               </a:rPr>
-              <a:t>Monsoon Concentration: ~79% of rain falls in Jun–Sep. Deseasonalized temp-rain ρ = -0.21.</a:t>
+              <a:t>Monsoon Concentration: ~78% of rainfall occurs in Jun–Sep. Deseasonalized temp-rain correlation: ρ = -0.21.</a:t>
             </a:r>
           </a:p>
         </p:txBody>

</xml_diff>